<commit_message>
Aplica tema da Mandala aura 360 e a logo da Aura na apresentação de R&S
- Nova paleta baseada na Mandala aura 360 (navy / coral / teal) no lugar
  de azul/amarelo/cinza:
  * atividades em navy, decisões (losangos) em coral
  * fluxo paralelo de Triagem Patrimonial em teal
  * conclusão/onboarding e caminhos "Sim" em teal; encerramentos em brick
- Capa usa a Mandala aura 360 como elemento gráfico de RH (cultura/pessoas)
- Logo da Aura aplicada: versão branca nos cabeçalhos (navy) e no rodapé
  da capa; versão original (recortada) no rodapé da capa sobre fundo claro
- Assets derivados (não altera o aura_logo.png original):
  * rh/mandala_wheel.png (recorte circular da mandala)
  * rh/aura_logo_trim.png (logo recortada, fundo transparente)
  * rh/aura_logo_white.png (logo em branco para fundos escuros)

Gerado via `node index.js`.

Co-Authored-By: Claude Opus 4.8 <noreply@anthropic.com>
Claude-Session: https://claude.ai/code/session_01N4K3kbx7gsDFdc6RDBtr3z
</commit_message>
<xml_diff>
--- a/Fluxo_Recrutamento_Selecao.pptx
+++ b/Fluxo_Recrutamento_Selecao.pptx
@@ -1062,13 +1062,13 @@
         <p:spPr>
           <a:xfrm>
             <a:off x="0" y="0"/>
-            <a:ext cx="4480560" cy="6858000"/>
-          </a:xfrm>
-          <a:prstGeom prst="rect">
-            <a:avLst/>
-          </a:prstGeom>
-          <a:solidFill>
-            <a:srgbClr val="16305C"/>
+            <a:ext cx="5029200" cy="6858000"/>
+          </a:xfrm>
+          <a:prstGeom prst="rect">
+            <a:avLst/>
+          </a:prstGeom>
+          <a:solidFill>
+            <a:srgbClr val="0E1F5D"/>
           </a:solidFill>
           <a:ln/>
         </p:spPr>
@@ -1081,14 +1081,14 @@
         </p:nvSpPr>
         <p:spPr>
           <a:xfrm>
-            <a:off x="4480560" y="0"/>
+            <a:off x="5029200" y="0"/>
             <a:ext cx="109728" cy="6858000"/>
           </a:xfrm>
           <a:prstGeom prst="rect">
             <a:avLst/>
           </a:prstGeom>
           <a:solidFill>
-            <a:srgbClr val="F5B301"/>
+            <a:srgbClr val="E45D4A"/>
           </a:solidFill>
           <a:ln/>
         </p:spPr>
@@ -1101,14 +1101,16 @@
         </p:nvSpPr>
         <p:spPr>
           <a:xfrm>
-            <a:off x="3108960" y="-1371600"/>
+            <a:off x="3657600" y="-1463040"/>
             <a:ext cx="2743200" cy="2743200"/>
           </a:xfrm>
           <a:prstGeom prst="ellipse">
             <a:avLst/>
           </a:prstGeom>
           <a:solidFill>
-            <a:srgbClr val="1F4E9B"/>
+            <a:srgbClr val="0D6665">
+              <a:alpha val="55000"/>
+            </a:srgbClr>
           </a:solidFill>
           <a:ln/>
         </p:spPr>
@@ -1121,346 +1123,54 @@
         </p:nvSpPr>
         <p:spPr>
           <a:xfrm>
-            <a:off x="-914400" y="5212080"/>
-            <a:ext cx="2194560" cy="2194560"/>
+            <a:off x="-1097280" y="5394960"/>
+            <a:ext cx="2377440" cy="2377440"/>
           </a:xfrm>
           <a:prstGeom prst="ellipse">
             <a:avLst/>
           </a:prstGeom>
           <a:solidFill>
-            <a:srgbClr val="2E6CC4"/>
-          </a:solidFill>
-          <a:ln/>
-        </p:spPr>
-      </p:sp>
-      <p:sp>
-        <p:nvSpPr>
-          <p:cNvPr id="6" name="Shape 4"/>
-          <p:cNvSpPr/>
-          <p:nvPr/>
-        </p:nvSpPr>
-        <p:spPr>
-          <a:xfrm flipH="1">
-            <a:off x="1234440" y="2468880"/>
-            <a:ext cx="1005840" cy="1005840"/>
-          </a:xfrm>
-          <a:prstGeom prst="line">
-            <a:avLst/>
-          </a:prstGeom>
-          <a:noFill/>
-          <a:ln w="15240">
-            <a:solidFill>
-              <a:srgbClr val="3E5C8A"/>
-            </a:solidFill>
-            <a:prstDash val="solid"/>
-            <a:headEnd type="none"/>
-            <a:tailEnd type="none"/>
-          </a:ln>
-        </p:spPr>
-      </p:sp>
-      <p:sp>
-        <p:nvSpPr>
-          <p:cNvPr id="7" name="Shape 5"/>
-          <p:cNvSpPr/>
-          <p:nvPr/>
-        </p:nvSpPr>
-        <p:spPr>
-          <a:xfrm>
-            <a:off x="2240280" y="2468880"/>
-            <a:ext cx="1005840" cy="1005840"/>
-          </a:xfrm>
-          <a:prstGeom prst="line">
-            <a:avLst/>
-          </a:prstGeom>
-          <a:noFill/>
-          <a:ln w="15240">
-            <a:solidFill>
-              <a:srgbClr val="3E5C8A"/>
-            </a:solidFill>
-            <a:prstDash val="solid"/>
-            <a:headEnd type="none"/>
-            <a:tailEnd type="none"/>
-          </a:ln>
-        </p:spPr>
-      </p:sp>
-      <p:sp>
-        <p:nvSpPr>
-          <p:cNvPr id="8" name="Shape 6"/>
-          <p:cNvSpPr/>
-          <p:nvPr/>
-        </p:nvSpPr>
-        <p:spPr>
-          <a:xfrm>
-            <a:off x="2240280" y="2468880"/>
-            <a:ext cx="0" cy="2011680"/>
-          </a:xfrm>
-          <a:prstGeom prst="line">
-            <a:avLst/>
-          </a:prstGeom>
-          <a:noFill/>
-          <a:ln w="15240">
-            <a:solidFill>
-              <a:srgbClr val="3E5C8A"/>
-            </a:solidFill>
-            <a:prstDash val="solid"/>
-            <a:headEnd type="none"/>
-            <a:tailEnd type="none"/>
-          </a:ln>
-        </p:spPr>
-      </p:sp>
-      <p:sp>
-        <p:nvSpPr>
-          <p:cNvPr id="9" name="Shape 7"/>
-          <p:cNvSpPr/>
-          <p:nvPr/>
-        </p:nvSpPr>
-        <p:spPr>
-          <a:xfrm>
-            <a:off x="1234440" y="3474720"/>
-            <a:ext cx="2011680" cy="0"/>
-          </a:xfrm>
-          <a:prstGeom prst="line">
-            <a:avLst/>
-          </a:prstGeom>
-          <a:noFill/>
-          <a:ln w="15240">
-            <a:solidFill>
-              <a:srgbClr val="3E5C8A"/>
-            </a:solidFill>
-            <a:prstDash val="solid"/>
-            <a:headEnd type="none"/>
-            <a:tailEnd type="none"/>
-          </a:ln>
-        </p:spPr>
-      </p:sp>
-      <p:sp>
-        <p:nvSpPr>
-          <p:cNvPr id="10" name="Shape 8"/>
-          <p:cNvSpPr/>
-          <p:nvPr/>
-        </p:nvSpPr>
-        <p:spPr>
-          <a:xfrm>
-            <a:off x="1234440" y="3474720"/>
-            <a:ext cx="1005840" cy="1005840"/>
-          </a:xfrm>
-          <a:prstGeom prst="line">
-            <a:avLst/>
-          </a:prstGeom>
-          <a:noFill/>
-          <a:ln w="15240">
-            <a:solidFill>
-              <a:srgbClr val="3E5C8A"/>
-            </a:solidFill>
-            <a:prstDash val="solid"/>
-            <a:headEnd type="none"/>
-            <a:tailEnd type="none"/>
-          </a:ln>
-        </p:spPr>
-      </p:sp>
-      <p:sp>
-        <p:nvSpPr>
-          <p:cNvPr id="11" name="Shape 9"/>
-          <p:cNvSpPr/>
-          <p:nvPr/>
-        </p:nvSpPr>
-        <p:spPr>
-          <a:xfrm flipH="1">
-            <a:off x="2240280" y="3474720"/>
-            <a:ext cx="1005840" cy="1005840"/>
-          </a:xfrm>
-          <a:prstGeom prst="line">
-            <a:avLst/>
-          </a:prstGeom>
-          <a:noFill/>
-          <a:ln w="15240">
-            <a:solidFill>
-              <a:srgbClr val="3E5C8A"/>
-            </a:solidFill>
-            <a:prstDash val="solid"/>
-            <a:headEnd type="none"/>
-            <a:tailEnd type="none"/>
-          </a:ln>
-        </p:spPr>
-      </p:sp>
-      <p:sp>
-        <p:nvSpPr>
-          <p:cNvPr id="12" name="Shape 10"/>
-          <p:cNvSpPr/>
-          <p:nvPr/>
-        </p:nvSpPr>
-        <p:spPr>
-          <a:xfrm>
-            <a:off x="2068830" y="2160270"/>
-            <a:ext cx="342900" cy="342900"/>
-          </a:xfrm>
-          <a:prstGeom prst="ellipse">
-            <a:avLst/>
-          </a:prstGeom>
-          <a:solidFill>
-            <a:srgbClr val="F5B301"/>
-          </a:solidFill>
-          <a:ln/>
-        </p:spPr>
-      </p:sp>
-      <p:sp>
-        <p:nvSpPr>
-          <p:cNvPr id="13" name="Shape 11"/>
-          <p:cNvSpPr/>
-          <p:nvPr/>
-        </p:nvSpPr>
-        <p:spPr>
-          <a:xfrm>
-            <a:off x="1931670" y="2480310"/>
-            <a:ext cx="617220" cy="388620"/>
-          </a:xfrm>
-          <a:prstGeom prst="roundRect">
-            <a:avLst>
-              <a:gd name="adj" fmla="val 41176"/>
-            </a:avLst>
-          </a:prstGeom>
-          <a:solidFill>
-            <a:srgbClr val="F5B301"/>
-          </a:solidFill>
-          <a:ln/>
-        </p:spPr>
-      </p:sp>
-      <p:sp>
-        <p:nvSpPr>
-          <p:cNvPr id="14" name="Shape 12"/>
-          <p:cNvSpPr/>
-          <p:nvPr/>
-        </p:nvSpPr>
-        <p:spPr>
-          <a:xfrm>
-            <a:off x="1097280" y="3200400"/>
-            <a:ext cx="274320" cy="274320"/>
-          </a:xfrm>
-          <a:prstGeom prst="ellipse">
-            <a:avLst/>
-          </a:prstGeom>
-          <a:solidFill>
-            <a:srgbClr val="FFFFFF"/>
-          </a:solidFill>
-          <a:ln/>
-        </p:spPr>
-      </p:sp>
-      <p:sp>
-        <p:nvSpPr>
-          <p:cNvPr id="15" name="Shape 13"/>
-          <p:cNvSpPr/>
-          <p:nvPr/>
-        </p:nvSpPr>
-        <p:spPr>
-          <a:xfrm>
-            <a:off x="987552" y="3456432"/>
-            <a:ext cx="493776" cy="310896"/>
-          </a:xfrm>
-          <a:prstGeom prst="roundRect">
-            <a:avLst>
-              <a:gd name="adj" fmla="val 41176"/>
-            </a:avLst>
-          </a:prstGeom>
-          <a:solidFill>
-            <a:srgbClr val="FFFFFF"/>
-          </a:solidFill>
-          <a:ln/>
-        </p:spPr>
-      </p:sp>
-      <p:sp>
-        <p:nvSpPr>
-          <p:cNvPr id="16" name="Shape 14"/>
-          <p:cNvSpPr/>
-          <p:nvPr/>
-        </p:nvSpPr>
-        <p:spPr>
-          <a:xfrm>
-            <a:off x="3108960" y="3200400"/>
-            <a:ext cx="274320" cy="274320"/>
-          </a:xfrm>
-          <a:prstGeom prst="ellipse">
-            <a:avLst/>
-          </a:prstGeom>
-          <a:solidFill>
-            <a:srgbClr val="FFFFFF"/>
-          </a:solidFill>
-          <a:ln/>
-        </p:spPr>
-      </p:sp>
-      <p:sp>
-        <p:nvSpPr>
-          <p:cNvPr id="17" name="Shape 15"/>
-          <p:cNvSpPr/>
-          <p:nvPr/>
-        </p:nvSpPr>
-        <p:spPr>
-          <a:xfrm>
-            <a:off x="2999232" y="3456432"/>
-            <a:ext cx="493776" cy="310896"/>
-          </a:xfrm>
-          <a:prstGeom prst="roundRect">
-            <a:avLst>
-              <a:gd name="adj" fmla="val 41176"/>
-            </a:avLst>
-          </a:prstGeom>
-          <a:solidFill>
-            <a:srgbClr val="FFFFFF"/>
-          </a:solidFill>
-          <a:ln/>
-        </p:spPr>
-      </p:sp>
-      <p:sp>
-        <p:nvSpPr>
-          <p:cNvPr id="18" name="Shape 16"/>
-          <p:cNvSpPr/>
-          <p:nvPr/>
-        </p:nvSpPr>
-        <p:spPr>
-          <a:xfrm>
-            <a:off x="2096262" y="4199382"/>
-            <a:ext cx="288036" cy="288036"/>
-          </a:xfrm>
-          <a:prstGeom prst="ellipse">
-            <a:avLst/>
-          </a:prstGeom>
-          <a:solidFill>
-            <a:srgbClr val="2E6CC4"/>
-          </a:solidFill>
-          <a:ln/>
-        </p:spPr>
-      </p:sp>
-      <p:sp>
-        <p:nvSpPr>
-          <p:cNvPr id="19" name="Shape 17"/>
-          <p:cNvSpPr/>
-          <p:nvPr/>
-        </p:nvSpPr>
-        <p:spPr>
-          <a:xfrm>
-            <a:off x="1981048" y="4468216"/>
-            <a:ext cx="518465" cy="326441"/>
-          </a:xfrm>
-          <a:prstGeom prst="roundRect">
-            <a:avLst>
-              <a:gd name="adj" fmla="val 41176"/>
-            </a:avLst>
-          </a:prstGeom>
-          <a:solidFill>
-            <a:srgbClr val="2E6CC4"/>
-          </a:solidFill>
-          <a:ln/>
-        </p:spPr>
-      </p:sp>
-      <p:sp>
-        <p:nvSpPr>
-          <p:cNvPr id="20" name="Text 18"/>
-          <p:cNvSpPr/>
-          <p:nvPr/>
-        </p:nvSpPr>
-        <p:spPr>
-          <a:xfrm>
-            <a:off x="502920" y="502920"/>
-            <a:ext cx="3657600" cy="365760"/>
+            <a:srgbClr val="C0402F">
+              <a:alpha val="45000"/>
+            </a:srgbClr>
+          </a:solidFill>
+          <a:ln/>
+        </p:spPr>
+      </p:sp>
+      <p:pic>
+        <p:nvPicPr>
+          <p:cNvPr id="6" name="Image 0" descr="/home/user/PPT---RH/rh/mandala_wheel.png">    </p:cNvPr>
+          <p:cNvPicPr>
+            <a:picLocks noChangeAspect="1"/>
+          </p:cNvPicPr>
+          <p:nvPr/>
+        </p:nvPicPr>
+        <p:blipFill>
+          <a:blip r:embed="rId1"/>
+          <a:stretch>
+            <a:fillRect/>
+          </a:stretch>
+        </p:blipFill>
+        <p:spPr>
+          <a:xfrm>
+            <a:off x="502920" y="1783080"/>
+            <a:ext cx="4023360" cy="4023360"/>
+          </a:xfrm>
+          <a:prstGeom prst="rect">
+            <a:avLst/>
+          </a:prstGeom>
+        </p:spPr>
+      </p:pic>
+      <p:sp>
+        <p:nvSpPr>
+          <p:cNvPr id="7" name="Text 4"/>
+          <p:cNvSpPr/>
+          <p:nvPr/>
+        </p:nvSpPr>
+        <p:spPr>
+          <a:xfrm>
+            <a:off x="548640" y="457200"/>
+            <a:ext cx="4114800" cy="365760"/>
           </a:xfrm>
           <a:prstGeom prst="rect">
             <a:avLst/>
@@ -1478,7 +1188,7 @@
             <a:r>
               <a:rPr lang="en-US" sz="1200" b="1" spc="100" kern="0" dirty="0">
                 <a:solidFill>
-                  <a:srgbClr val="F5B301"/>
+                  <a:srgbClr val="E45D4A"/>
                 </a:solidFill>
                 <a:latin typeface="Calibri" pitchFamily="34" charset="0"/>
                 <a:ea typeface="Calibri" pitchFamily="34" charset="-122"/>
@@ -1490,16 +1200,40 @@
           </a:p>
         </p:txBody>
       </p:sp>
-      <p:sp>
-        <p:nvSpPr>
-          <p:cNvPr id="21" name="Text 19"/>
-          <p:cNvSpPr/>
-          <p:nvPr/>
-        </p:nvSpPr>
-        <p:spPr>
-          <a:xfrm>
-            <a:off x="4983480" y="2057400"/>
-            <a:ext cx="6675120" cy="1737360"/>
+      <p:pic>
+        <p:nvPicPr>
+          <p:cNvPr id="8" name="Image 1" descr="/home/user/PPT---RH/rh/aura_logo_white.png">    </p:cNvPr>
+          <p:cNvPicPr>
+            <a:picLocks noChangeAspect="1"/>
+          </p:cNvPicPr>
+          <p:nvPr/>
+        </p:nvPicPr>
+        <p:blipFill>
+          <a:blip r:embed="rId2"/>
+          <a:stretch>
+            <a:fillRect/>
+          </a:stretch>
+        </p:blipFill>
+        <p:spPr>
+          <a:xfrm>
+            <a:off x="548640" y="5943600"/>
+            <a:ext cx="1188720" cy="694944"/>
+          </a:xfrm>
+          <a:prstGeom prst="rect">
+            <a:avLst/>
+          </a:prstGeom>
+        </p:spPr>
+      </p:pic>
+      <p:sp>
+        <p:nvSpPr>
+          <p:cNvPr id="9" name="Text 5"/>
+          <p:cNvSpPr/>
+          <p:nvPr/>
+        </p:nvSpPr>
+        <p:spPr>
+          <a:xfrm>
+            <a:off x="5486400" y="2011680"/>
+            <a:ext cx="6309360" cy="1737360"/>
           </a:xfrm>
           <a:prstGeom prst="rect">
             <a:avLst/>
@@ -1518,9 +1252,9 @@
               <a:buNone/>
             </a:pPr>
             <a:r>
-              <a:rPr lang="en-US" sz="3400" b="1" dirty="0">
-                <a:solidFill>
-                  <a:srgbClr val="16305C"/>
+              <a:rPr lang="en-US" sz="3300" b="1" dirty="0">
+                <a:solidFill>
+                  <a:srgbClr val="22346B"/>
                 </a:solidFill>
                 <a:latin typeface="Calibri" pitchFamily="34" charset="0"/>
                 <a:ea typeface="Calibri" pitchFamily="34" charset="-122"/>
@@ -1528,7 +1262,7 @@
               </a:rPr>
               <a:t>Fluxo do Processo de</a:t>
             </a:r>
-            <a:endParaRPr lang="en-US" sz="3400" dirty="0"/>
+            <a:endParaRPr lang="en-US" sz="3300" dirty="0"/>
           </a:p>
           <a:p>
             <a:pPr algn="l" indent="0" marL="0">
@@ -1538,9 +1272,9 @@
               <a:buNone/>
             </a:pPr>
             <a:r>
-              <a:rPr lang="en-US" sz="3400" b="1" dirty="0">
-                <a:solidFill>
-                  <a:srgbClr val="1F4E9B"/>
+              <a:rPr lang="en-US" sz="3300" b="1" dirty="0">
+                <a:solidFill>
+                  <a:srgbClr val="E45D4A"/>
                 </a:solidFill>
                 <a:latin typeface="Calibri" pitchFamily="34" charset="0"/>
                 <a:ea typeface="Calibri" pitchFamily="34" charset="-122"/>
@@ -1548,40 +1282,40 @@
               </a:rPr>
               <a:t>Recrutamento e Seleção</a:t>
             </a:r>
-            <a:endParaRPr lang="en-US" sz="3400" dirty="0"/>
-          </a:p>
-        </p:txBody>
-      </p:sp>
-      <p:sp>
-        <p:nvSpPr>
-          <p:cNvPr id="22" name="Shape 20"/>
-          <p:cNvSpPr/>
-          <p:nvPr/>
-        </p:nvSpPr>
-        <p:spPr>
-          <a:xfrm>
-            <a:off x="5029200" y="3886200"/>
+            <a:endParaRPr lang="en-US" sz="3300" dirty="0"/>
+          </a:p>
+        </p:txBody>
+      </p:sp>
+      <p:sp>
+        <p:nvSpPr>
+          <p:cNvPr id="10" name="Shape 6"/>
+          <p:cNvSpPr/>
+          <p:nvPr/>
+        </p:nvSpPr>
+        <p:spPr>
+          <a:xfrm>
+            <a:off x="5532120" y="3858768"/>
             <a:ext cx="1554480" cy="54864"/>
           </a:xfrm>
           <a:prstGeom prst="rect">
             <a:avLst/>
           </a:prstGeom>
           <a:solidFill>
-            <a:srgbClr val="F5B301"/>
-          </a:solidFill>
-          <a:ln/>
-        </p:spPr>
-      </p:sp>
-      <p:sp>
-        <p:nvSpPr>
-          <p:cNvPr id="23" name="Text 21"/>
-          <p:cNvSpPr/>
-          <p:nvPr/>
-        </p:nvSpPr>
-        <p:spPr>
-          <a:xfrm>
-            <a:off x="4983480" y="4069080"/>
-            <a:ext cx="6583680" cy="822960"/>
+            <a:srgbClr val="E45D4A"/>
+          </a:solidFill>
+          <a:ln/>
+        </p:spPr>
+      </p:sp>
+      <p:sp>
+        <p:nvSpPr>
+          <p:cNvPr id="11" name="Text 7"/>
+          <p:cNvSpPr/>
+          <p:nvPr/>
+        </p:nvSpPr>
+        <p:spPr>
+          <a:xfrm>
+            <a:off x="5486400" y="4041648"/>
+            <a:ext cx="6126480" cy="822960"/>
           </a:xfrm>
           <a:prstGeom prst="rect">
             <a:avLst/>
@@ -1599,7 +1333,7 @@
             <a:r>
               <a:rPr lang="en-US" sz="1500" dirty="0">
                 <a:solidFill>
-                  <a:srgbClr val="6B7480"/>
+                  <a:srgbClr val="5B6672"/>
                 </a:solidFill>
                 <a:latin typeface="Calibri" pitchFamily="34" charset="0"/>
                 <a:ea typeface="Calibri" pitchFamily="34" charset="-122"/>
@@ -1613,14 +1347,14 @@
       </p:sp>
       <p:sp>
         <p:nvSpPr>
-          <p:cNvPr id="24" name="Text 22"/>
-          <p:cNvSpPr/>
-          <p:nvPr/>
-        </p:nvSpPr>
-        <p:spPr>
-          <a:xfrm>
-            <a:off x="4983480" y="6172200"/>
-            <a:ext cx="6583680" cy="365760"/>
+          <p:cNvPr id="12" name="Text 8"/>
+          <p:cNvSpPr/>
+          <p:nvPr/>
+        </p:nvSpPr>
+        <p:spPr>
+          <a:xfrm>
+            <a:off x="5486400" y="6126480"/>
+            <a:ext cx="4572000" cy="365760"/>
           </a:xfrm>
           <a:prstGeom prst="rect">
             <a:avLst/>
@@ -1638,7 +1372,7 @@
             <a:r>
               <a:rPr lang="en-US" sz="1000" b="1" dirty="0">
                 <a:solidFill>
-                  <a:srgbClr val="6B7480"/>
+                  <a:srgbClr val="5B6672"/>
                 </a:solidFill>
                 <a:latin typeface="Calibri" pitchFamily="34" charset="0"/>
                 <a:ea typeface="Calibri" pitchFamily="34" charset="-122"/>
@@ -1650,6 +1384,30 @@
           </a:p>
         </p:txBody>
       </p:sp>
+      <p:pic>
+        <p:nvPicPr>
+          <p:cNvPr id="13" name="Image 2" descr="/home/user/PPT---RH/rh/aura_logo_trim.png">    </p:cNvPr>
+          <p:cNvPicPr>
+            <a:picLocks noChangeAspect="1"/>
+          </p:cNvPicPr>
+          <p:nvPr/>
+        </p:nvPicPr>
+        <p:blipFill>
+          <a:blip r:embed="rId3"/>
+          <a:stretch>
+            <a:fillRect/>
+          </a:stretch>
+        </p:blipFill>
+        <p:spPr>
+          <a:xfrm>
+            <a:off x="10469880" y="5806440"/>
+            <a:ext cx="1234440" cy="722376"/>
+          </a:xfrm>
+          <a:prstGeom prst="rect">
+            <a:avLst/>
+          </a:prstGeom>
+        </p:spPr>
+      </p:pic>
     </p:spTree>
   </p:cSld>
   <p:clrMapOvr>
@@ -1697,7 +1455,7 @@
             <a:avLst/>
           </a:prstGeom>
           <a:solidFill>
-            <a:srgbClr val="16305C"/>
+            <a:srgbClr val="22346B"/>
           </a:solidFill>
           <a:ln/>
         </p:spPr>
@@ -1717,7 +1475,7 @@
             <a:avLst/>
           </a:prstGeom>
           <a:solidFill>
-            <a:srgbClr val="F5B301"/>
+            <a:srgbClr val="E45D4A"/>
           </a:solidFill>
           <a:ln/>
         </p:spPr>
@@ -1731,7 +1489,7 @@
         <p:spPr>
           <a:xfrm>
             <a:off x="365760" y="0"/>
-            <a:ext cx="8229600" cy="786384"/>
+            <a:ext cx="7863840" cy="786384"/>
           </a:xfrm>
           <a:prstGeom prst="rect">
             <a:avLst/>
@@ -1769,8 +1527,8 @@
         </p:nvSpPr>
         <p:spPr>
           <a:xfrm>
-            <a:off x="8595360" y="0"/>
-            <a:ext cx="3291840" cy="786384"/>
+            <a:off x="8229600" y="0"/>
+            <a:ext cx="2148840" cy="786384"/>
           </a:xfrm>
           <a:prstGeom prst="rect">
             <a:avLst/>
@@ -1788,7 +1546,7 @@
             <a:r>
               <a:rPr lang="en-US" sz="1100" b="1" dirty="0">
                 <a:solidFill>
-                  <a:srgbClr val="F5B301"/>
+                  <a:srgbClr val="E45D4A"/>
                 </a:solidFill>
                 <a:latin typeface="Calibri" pitchFamily="34" charset="0"/>
                 <a:ea typeface="Calibri" pitchFamily="34" charset="-122"/>
@@ -1800,9 +1558,33 @@
           </a:p>
         </p:txBody>
       </p:sp>
-      <p:sp>
-        <p:nvSpPr>
-          <p:cNvPr id="6" name="Shape 4"/>
+      <p:pic>
+        <p:nvPicPr>
+          <p:cNvPr id="6" name="Image 0" descr="/home/user/PPT---RH/rh/aura_logo_white.png">    </p:cNvPr>
+          <p:cNvPicPr>
+            <a:picLocks noChangeAspect="1"/>
+          </p:cNvPicPr>
+          <p:nvPr/>
+        </p:nvPicPr>
+        <p:blipFill>
+          <a:blip r:embed="rId1"/>
+          <a:stretch>
+            <a:fillRect/>
+          </a:stretch>
+        </p:blipFill>
+        <p:spPr>
+          <a:xfrm>
+            <a:off x="10927080" y="155448"/>
+            <a:ext cx="813816" cy="475488"/>
+          </a:xfrm>
+          <a:prstGeom prst="rect">
+            <a:avLst/>
+          </a:prstGeom>
+        </p:spPr>
+      </p:pic>
+      <p:sp>
+        <p:nvSpPr>
+          <p:cNvPr id="7" name="Shape 4"/>
           <p:cNvSpPr/>
           <p:nvPr/>
         </p:nvSpPr>
@@ -1831,7 +1613,7 @@
       </p:sp>
       <p:sp>
         <p:nvSpPr>
-          <p:cNvPr id="7" name="Shape 5"/>
+          <p:cNvPr id="8" name="Shape 5"/>
           <p:cNvSpPr/>
           <p:nvPr/>
         </p:nvSpPr>
@@ -1844,14 +1626,14 @@
             <a:avLst/>
           </a:prstGeom>
           <a:solidFill>
-            <a:srgbClr val="1F4E9B"/>
-          </a:solidFill>
-          <a:ln/>
-        </p:spPr>
-      </p:sp>
-      <p:sp>
-        <p:nvSpPr>
-          <p:cNvPr id="8" name="Shape 6"/>
+            <a:srgbClr val="22346B"/>
+          </a:solidFill>
+          <a:ln/>
+        </p:spPr>
+      </p:sp>
+      <p:sp>
+        <p:nvSpPr>
+          <p:cNvPr id="9" name="Shape 6"/>
           <p:cNvSpPr/>
           <p:nvPr/>
         </p:nvSpPr>
@@ -1864,7 +1646,7 @@
             <a:avLst/>
           </a:prstGeom>
           <a:solidFill>
-            <a:srgbClr val="1F4E9B"/>
+            <a:srgbClr val="22346B"/>
           </a:solidFill>
           <a:ln/>
           <a:effectLst>
@@ -1878,7 +1660,7 @@
       </p:sp>
       <p:sp>
         <p:nvSpPr>
-          <p:cNvPr id="9" name="Text 7"/>
+          <p:cNvPr id="10" name="Text 7"/>
           <p:cNvSpPr/>
           <p:nvPr/>
         </p:nvSpPr>
@@ -1917,7 +1699,7 @@
       </p:sp>
       <p:sp>
         <p:nvSpPr>
-          <p:cNvPr id="10" name="Text 8"/>
+          <p:cNvPr id="11" name="Text 8"/>
           <p:cNvSpPr/>
           <p:nvPr/>
         </p:nvSpPr>
@@ -1945,7 +1727,7 @@
             <a:r>
               <a:rPr lang="en-US" sz="1150" b="1" dirty="0">
                 <a:solidFill>
-                  <a:srgbClr val="16305C"/>
+                  <a:srgbClr val="22346B"/>
                 </a:solidFill>
                 <a:latin typeface="Calibri" pitchFamily="34" charset="0"/>
                 <a:ea typeface="Calibri" pitchFamily="34" charset="-122"/>
@@ -1965,7 +1747,7 @@
             <a:r>
               <a:rPr lang="en-US" sz="800" dirty="0">
                 <a:solidFill>
-                  <a:srgbClr val="6B7480"/>
+                  <a:srgbClr val="5B6672"/>
                 </a:solidFill>
                 <a:latin typeface="Calibri" pitchFamily="34" charset="0"/>
                 <a:ea typeface="Calibri" pitchFamily="34" charset="-122"/>
@@ -1985,7 +1767,7 @@
             <a:r>
               <a:rPr lang="en-US" sz="800" dirty="0">
                 <a:solidFill>
-                  <a:srgbClr val="6B7480"/>
+                  <a:srgbClr val="5B6672"/>
                 </a:solidFill>
                 <a:latin typeface="Calibri" pitchFamily="34" charset="0"/>
                 <a:ea typeface="Calibri" pitchFamily="34" charset="-122"/>
@@ -2005,7 +1787,7 @@
             <a:r>
               <a:rPr lang="en-US" sz="800" dirty="0">
                 <a:solidFill>
-                  <a:srgbClr val="6B7480"/>
+                  <a:srgbClr val="5B6672"/>
                 </a:solidFill>
                 <a:latin typeface="Calibri" pitchFamily="34" charset="0"/>
                 <a:ea typeface="Calibri" pitchFamily="34" charset="-122"/>
@@ -2019,7 +1801,7 @@
       </p:sp>
       <p:sp>
         <p:nvSpPr>
-          <p:cNvPr id="11" name="Shape 9"/>
+          <p:cNvPr id="12" name="Shape 9"/>
           <p:cNvSpPr/>
           <p:nvPr/>
         </p:nvSpPr>
@@ -2048,7 +1830,7 @@
       </p:sp>
       <p:sp>
         <p:nvSpPr>
-          <p:cNvPr id="12" name="Shape 10"/>
+          <p:cNvPr id="13" name="Shape 10"/>
           <p:cNvSpPr/>
           <p:nvPr/>
         </p:nvSpPr>
@@ -2061,14 +1843,14 @@
             <a:avLst/>
           </a:prstGeom>
           <a:solidFill>
-            <a:srgbClr val="1F4E9B"/>
-          </a:solidFill>
-          <a:ln/>
-        </p:spPr>
-      </p:sp>
-      <p:sp>
-        <p:nvSpPr>
-          <p:cNvPr id="13" name="Shape 11"/>
+            <a:srgbClr val="22346B"/>
+          </a:solidFill>
+          <a:ln/>
+        </p:spPr>
+      </p:sp>
+      <p:sp>
+        <p:nvSpPr>
+          <p:cNvPr id="14" name="Shape 11"/>
           <p:cNvSpPr/>
           <p:nvPr/>
         </p:nvSpPr>
@@ -2081,7 +1863,7 @@
             <a:avLst/>
           </a:prstGeom>
           <a:solidFill>
-            <a:srgbClr val="1F4E9B"/>
+            <a:srgbClr val="22346B"/>
           </a:solidFill>
           <a:ln/>
           <a:effectLst>
@@ -2095,7 +1877,7 @@
       </p:sp>
       <p:sp>
         <p:nvSpPr>
-          <p:cNvPr id="14" name="Text 12"/>
+          <p:cNvPr id="15" name="Text 12"/>
           <p:cNvSpPr/>
           <p:nvPr/>
         </p:nvSpPr>
@@ -2134,7 +1916,7 @@
       </p:sp>
       <p:sp>
         <p:nvSpPr>
-          <p:cNvPr id="15" name="Text 13"/>
+          <p:cNvPr id="16" name="Text 13"/>
           <p:cNvSpPr/>
           <p:nvPr/>
         </p:nvSpPr>
@@ -2162,7 +1944,7 @@
             <a:r>
               <a:rPr lang="en-US" sz="1150" b="1" dirty="0">
                 <a:solidFill>
-                  <a:srgbClr val="16305C"/>
+                  <a:srgbClr val="22346B"/>
                 </a:solidFill>
                 <a:latin typeface="Calibri" pitchFamily="34" charset="0"/>
                 <a:ea typeface="Calibri" pitchFamily="34" charset="-122"/>
@@ -2182,7 +1964,7 @@
             <a:r>
               <a:rPr lang="en-US" sz="800" dirty="0">
                 <a:solidFill>
-                  <a:srgbClr val="6B7480"/>
+                  <a:srgbClr val="5B6672"/>
                 </a:solidFill>
                 <a:latin typeface="Calibri" pitchFamily="34" charset="0"/>
                 <a:ea typeface="Calibri" pitchFamily="34" charset="-122"/>
@@ -2202,7 +1984,7 @@
             <a:r>
               <a:rPr lang="en-US" sz="800" dirty="0">
                 <a:solidFill>
-                  <a:srgbClr val="6B7480"/>
+                  <a:srgbClr val="5B6672"/>
                 </a:solidFill>
                 <a:latin typeface="Calibri" pitchFamily="34" charset="0"/>
                 <a:ea typeface="Calibri" pitchFamily="34" charset="-122"/>
@@ -2222,7 +2004,7 @@
             <a:r>
               <a:rPr lang="en-US" sz="800" dirty="0">
                 <a:solidFill>
-                  <a:srgbClr val="6B7480"/>
+                  <a:srgbClr val="5B6672"/>
                 </a:solidFill>
                 <a:latin typeface="Calibri" pitchFamily="34" charset="0"/>
                 <a:ea typeface="Calibri" pitchFamily="34" charset="-122"/>
@@ -2236,7 +2018,7 @@
       </p:sp>
       <p:sp>
         <p:nvSpPr>
-          <p:cNvPr id="16" name="Shape 14"/>
+          <p:cNvPr id="17" name="Shape 14"/>
           <p:cNvSpPr/>
           <p:nvPr/>
         </p:nvSpPr>
@@ -2265,7 +2047,7 @@
       </p:sp>
       <p:sp>
         <p:nvSpPr>
-          <p:cNvPr id="17" name="Shape 15"/>
+          <p:cNvPr id="18" name="Shape 15"/>
           <p:cNvSpPr/>
           <p:nvPr/>
         </p:nvSpPr>
@@ -2278,14 +2060,14 @@
             <a:avLst/>
           </a:prstGeom>
           <a:solidFill>
-            <a:srgbClr val="1F4E9B"/>
-          </a:solidFill>
-          <a:ln/>
-        </p:spPr>
-      </p:sp>
-      <p:sp>
-        <p:nvSpPr>
-          <p:cNvPr id="18" name="Shape 16"/>
+            <a:srgbClr val="22346B"/>
+          </a:solidFill>
+          <a:ln/>
+        </p:spPr>
+      </p:sp>
+      <p:sp>
+        <p:nvSpPr>
+          <p:cNvPr id="19" name="Shape 16"/>
           <p:cNvSpPr/>
           <p:nvPr/>
         </p:nvSpPr>
@@ -2298,7 +2080,7 @@
             <a:avLst/>
           </a:prstGeom>
           <a:solidFill>
-            <a:srgbClr val="1F4E9B"/>
+            <a:srgbClr val="22346B"/>
           </a:solidFill>
           <a:ln/>
           <a:effectLst>
@@ -2312,7 +2094,7 @@
       </p:sp>
       <p:sp>
         <p:nvSpPr>
-          <p:cNvPr id="19" name="Text 17"/>
+          <p:cNvPr id="20" name="Text 17"/>
           <p:cNvSpPr/>
           <p:nvPr/>
         </p:nvSpPr>
@@ -2351,7 +2133,7 @@
       </p:sp>
       <p:sp>
         <p:nvSpPr>
-          <p:cNvPr id="20" name="Text 18"/>
+          <p:cNvPr id="21" name="Text 18"/>
           <p:cNvSpPr/>
           <p:nvPr/>
         </p:nvSpPr>
@@ -2379,7 +2161,7 @@
             <a:r>
               <a:rPr lang="en-US" sz="1150" b="1" dirty="0">
                 <a:solidFill>
-                  <a:srgbClr val="16305C"/>
+                  <a:srgbClr val="22346B"/>
                 </a:solidFill>
                 <a:latin typeface="Calibri" pitchFamily="34" charset="0"/>
                 <a:ea typeface="Calibri" pitchFamily="34" charset="-122"/>
@@ -2399,7 +2181,7 @@
             <a:r>
               <a:rPr lang="en-US" sz="800" dirty="0">
                 <a:solidFill>
-                  <a:srgbClr val="6B7480"/>
+                  <a:srgbClr val="5B6672"/>
                 </a:solidFill>
                 <a:latin typeface="Calibri" pitchFamily="34" charset="0"/>
                 <a:ea typeface="Calibri" pitchFamily="34" charset="-122"/>
@@ -2419,7 +2201,7 @@
             <a:r>
               <a:rPr lang="en-US" sz="800" dirty="0">
                 <a:solidFill>
-                  <a:srgbClr val="6B7480"/>
+                  <a:srgbClr val="5B6672"/>
                 </a:solidFill>
                 <a:latin typeface="Calibri" pitchFamily="34" charset="0"/>
                 <a:ea typeface="Calibri" pitchFamily="34" charset="-122"/>
@@ -2439,7 +2221,7 @@
             <a:r>
               <a:rPr lang="en-US" sz="800" dirty="0">
                 <a:solidFill>
-                  <a:srgbClr val="6B7480"/>
+                  <a:srgbClr val="5B6672"/>
                 </a:solidFill>
                 <a:latin typeface="Calibri" pitchFamily="34" charset="0"/>
                 <a:ea typeface="Calibri" pitchFamily="34" charset="-122"/>
@@ -2453,7 +2235,7 @@
       </p:sp>
       <p:sp>
         <p:nvSpPr>
-          <p:cNvPr id="21" name="Shape 19"/>
+          <p:cNvPr id="22" name="Shape 19"/>
           <p:cNvSpPr/>
           <p:nvPr/>
         </p:nvSpPr>
@@ -2482,7 +2264,7 @@
       </p:sp>
       <p:sp>
         <p:nvSpPr>
-          <p:cNvPr id="22" name="Shape 20"/>
+          <p:cNvPr id="23" name="Shape 20"/>
           <p:cNvSpPr/>
           <p:nvPr/>
         </p:nvSpPr>
@@ -2495,14 +2277,14 @@
             <a:avLst/>
           </a:prstGeom>
           <a:solidFill>
-            <a:srgbClr val="1F4E9B"/>
-          </a:solidFill>
-          <a:ln/>
-        </p:spPr>
-      </p:sp>
-      <p:sp>
-        <p:nvSpPr>
-          <p:cNvPr id="23" name="Shape 21"/>
+            <a:srgbClr val="22346B"/>
+          </a:solidFill>
+          <a:ln/>
+        </p:spPr>
+      </p:sp>
+      <p:sp>
+        <p:nvSpPr>
+          <p:cNvPr id="24" name="Shape 21"/>
           <p:cNvSpPr/>
           <p:nvPr/>
         </p:nvSpPr>
@@ -2515,7 +2297,7 @@
             <a:avLst/>
           </a:prstGeom>
           <a:solidFill>
-            <a:srgbClr val="1F4E9B"/>
+            <a:srgbClr val="22346B"/>
           </a:solidFill>
           <a:ln/>
           <a:effectLst>
@@ -2529,7 +2311,7 @@
       </p:sp>
       <p:sp>
         <p:nvSpPr>
-          <p:cNvPr id="24" name="Text 22"/>
+          <p:cNvPr id="25" name="Text 22"/>
           <p:cNvSpPr/>
           <p:nvPr/>
         </p:nvSpPr>
@@ -2568,7 +2350,7 @@
       </p:sp>
       <p:sp>
         <p:nvSpPr>
-          <p:cNvPr id="25" name="Text 23"/>
+          <p:cNvPr id="26" name="Text 23"/>
           <p:cNvSpPr/>
           <p:nvPr/>
         </p:nvSpPr>
@@ -2596,7 +2378,7 @@
             <a:r>
               <a:rPr lang="en-US" sz="1150" b="1" dirty="0">
                 <a:solidFill>
-                  <a:srgbClr val="16305C"/>
+                  <a:srgbClr val="22346B"/>
                 </a:solidFill>
                 <a:latin typeface="Calibri" pitchFamily="34" charset="0"/>
                 <a:ea typeface="Calibri" pitchFamily="34" charset="-122"/>
@@ -2616,7 +2398,7 @@
             <a:r>
               <a:rPr lang="en-US" sz="800" dirty="0">
                 <a:solidFill>
-                  <a:srgbClr val="6B7480"/>
+                  <a:srgbClr val="5B6672"/>
                 </a:solidFill>
                 <a:latin typeface="Calibri" pitchFamily="34" charset="0"/>
                 <a:ea typeface="Calibri" pitchFamily="34" charset="-122"/>
@@ -2636,7 +2418,7 @@
             <a:r>
               <a:rPr lang="en-US" sz="800" dirty="0">
                 <a:solidFill>
-                  <a:srgbClr val="6B7480"/>
+                  <a:srgbClr val="5B6672"/>
                 </a:solidFill>
                 <a:latin typeface="Calibri" pitchFamily="34" charset="0"/>
                 <a:ea typeface="Calibri" pitchFamily="34" charset="-122"/>
@@ -2656,7 +2438,7 @@
             <a:r>
               <a:rPr lang="en-US" sz="800" dirty="0">
                 <a:solidFill>
-                  <a:srgbClr val="6B7480"/>
+                  <a:srgbClr val="5B6672"/>
                 </a:solidFill>
                 <a:latin typeface="Calibri" pitchFamily="34" charset="0"/>
                 <a:ea typeface="Calibri" pitchFamily="34" charset="-122"/>
@@ -2670,7 +2452,7 @@
       </p:sp>
       <p:sp>
         <p:nvSpPr>
-          <p:cNvPr id="26" name="Shape 24"/>
+          <p:cNvPr id="27" name="Shape 24"/>
           <p:cNvSpPr/>
           <p:nvPr/>
         </p:nvSpPr>
@@ -2685,7 +2467,7 @@
           <a:noFill/>
           <a:ln w="22860">
             <a:solidFill>
-              <a:srgbClr val="2E6CC4"/>
+              <a:srgbClr val="34528A"/>
             </a:solidFill>
             <a:prstDash val="solid"/>
             <a:headEnd type="none"/>
@@ -2695,7 +2477,7 @@
       </p:sp>
       <p:sp>
         <p:nvSpPr>
-          <p:cNvPr id="27" name="Shape 25"/>
+          <p:cNvPr id="28" name="Shape 25"/>
           <p:cNvSpPr/>
           <p:nvPr/>
         </p:nvSpPr>
@@ -2710,7 +2492,7 @@
           <a:noFill/>
           <a:ln w="22860">
             <a:solidFill>
-              <a:srgbClr val="2E6CC4"/>
+              <a:srgbClr val="34528A"/>
             </a:solidFill>
             <a:prstDash val="solid"/>
             <a:headEnd type="none"/>
@@ -2720,7 +2502,7 @@
       </p:sp>
       <p:sp>
         <p:nvSpPr>
-          <p:cNvPr id="28" name="Shape 26"/>
+          <p:cNvPr id="29" name="Shape 26"/>
           <p:cNvSpPr/>
           <p:nvPr/>
         </p:nvSpPr>
@@ -2735,7 +2517,7 @@
           <a:noFill/>
           <a:ln w="22860">
             <a:solidFill>
-              <a:srgbClr val="2E6CC4"/>
+              <a:srgbClr val="34528A"/>
             </a:solidFill>
             <a:prstDash val="solid"/>
             <a:headEnd type="none"/>
@@ -2745,7 +2527,7 @@
       </p:sp>
       <p:sp>
         <p:nvSpPr>
-          <p:cNvPr id="29" name="Shape 27"/>
+          <p:cNvPr id="30" name="Shape 27"/>
           <p:cNvSpPr/>
           <p:nvPr/>
         </p:nvSpPr>
@@ -2760,7 +2542,7 @@
           <a:noFill/>
           <a:ln w="22860">
             <a:solidFill>
-              <a:srgbClr val="2E6CC4"/>
+              <a:srgbClr val="34528A"/>
             </a:solidFill>
             <a:prstDash val="solid"/>
             <a:headEnd type="none"/>
@@ -2770,7 +2552,7 @@
       </p:sp>
       <p:sp>
         <p:nvSpPr>
-          <p:cNvPr id="30" name="Shape 28"/>
+          <p:cNvPr id="31" name="Shape 28"/>
           <p:cNvSpPr/>
           <p:nvPr/>
         </p:nvSpPr>
@@ -2783,11 +2565,11 @@
             <a:avLst/>
           </a:prstGeom>
           <a:solidFill>
-            <a:srgbClr val="F5B301"/>
+            <a:srgbClr val="E45D4A"/>
           </a:solidFill>
           <a:ln w="12700">
             <a:solidFill>
-              <a:srgbClr val="D99400"/>
+              <a:srgbClr val="C0402F"/>
             </a:solidFill>
             <a:prstDash val="solid"/>
           </a:ln>
@@ -2802,7 +2584,7 @@
       </p:sp>
       <p:sp>
         <p:nvSpPr>
-          <p:cNvPr id="31" name="Text 29"/>
+          <p:cNvPr id="32" name="Text 29"/>
           <p:cNvSpPr/>
           <p:nvPr/>
         </p:nvSpPr>
@@ -2827,7 +2609,7 @@
             <a:r>
               <a:rPr lang="en-US" sz="900" b="1" dirty="0">
                 <a:solidFill>
-                  <a:srgbClr val="16305C"/>
+                  <a:srgbClr val="22346B"/>
                 </a:solidFill>
                 <a:latin typeface="Calibri" pitchFamily="34" charset="0"/>
                 <a:ea typeface="Calibri" pitchFamily="34" charset="-122"/>
@@ -2841,7 +2623,7 @@
       </p:sp>
       <p:sp>
         <p:nvSpPr>
-          <p:cNvPr id="32" name="Text 30"/>
+          <p:cNvPr id="33" name="Text 30"/>
           <p:cNvSpPr/>
           <p:nvPr/>
         </p:nvSpPr>
@@ -2866,7 +2648,7 @@
             <a:r>
               <a:rPr lang="en-US" sz="850" b="1" dirty="0">
                 <a:solidFill>
-                  <a:srgbClr val="C0504D"/>
+                  <a:srgbClr val="B23A2E"/>
                 </a:solidFill>
                 <a:latin typeface="Calibri" pitchFamily="34" charset="0"/>
                 <a:ea typeface="Calibri" pitchFamily="34" charset="-122"/>
@@ -2880,7 +2662,7 @@
       </p:sp>
       <p:sp>
         <p:nvSpPr>
-          <p:cNvPr id="33" name="Shape 31"/>
+          <p:cNvPr id="34" name="Shape 31"/>
           <p:cNvSpPr/>
           <p:nvPr/>
         </p:nvSpPr>
@@ -2895,7 +2677,7 @@
           <a:noFill/>
           <a:ln w="19050">
             <a:solidFill>
-              <a:srgbClr val="C0504D"/>
+              <a:srgbClr val="B23A2E"/>
             </a:solidFill>
             <a:prstDash val="solid"/>
             <a:headEnd type="none"/>
@@ -2905,7 +2687,7 @@
       </p:sp>
       <p:sp>
         <p:nvSpPr>
-          <p:cNvPr id="34" name="Shape 32"/>
+          <p:cNvPr id="35" name="Shape 32"/>
           <p:cNvSpPr/>
           <p:nvPr/>
         </p:nvSpPr>
@@ -2920,11 +2702,11 @@
             </a:avLst>
           </a:prstGeom>
           <a:solidFill>
-            <a:srgbClr val="F4DAD8"/>
+            <a:srgbClr val="F3DBD7"/>
           </a:solidFill>
           <a:ln w="12700">
             <a:solidFill>
-              <a:srgbClr val="C0504D"/>
+              <a:srgbClr val="B23A2E"/>
             </a:solidFill>
             <a:prstDash val="solid"/>
           </a:ln>
@@ -2939,7 +2721,7 @@
       </p:sp>
       <p:sp>
         <p:nvSpPr>
-          <p:cNvPr id="35" name="Text 33"/>
+          <p:cNvPr id="36" name="Text 33"/>
           <p:cNvSpPr/>
           <p:nvPr/>
         </p:nvSpPr>
@@ -2964,7 +2746,7 @@
             <a:r>
               <a:rPr lang="en-US" sz="800" b="1" dirty="0">
                 <a:solidFill>
-                  <a:srgbClr val="C0504D"/>
+                  <a:srgbClr val="B23A2E"/>
                 </a:solidFill>
                 <a:latin typeface="Calibri" pitchFamily="34" charset="0"/>
                 <a:ea typeface="Calibri" pitchFamily="34" charset="-122"/>
@@ -2978,7 +2760,7 @@
       </p:sp>
       <p:sp>
         <p:nvSpPr>
-          <p:cNvPr id="36" name="Shape 34"/>
+          <p:cNvPr id="37" name="Shape 34"/>
           <p:cNvSpPr/>
           <p:nvPr/>
         </p:nvSpPr>
@@ -2993,7 +2775,7 @@
           <a:noFill/>
           <a:ln w="17780">
             <a:solidFill>
-              <a:srgbClr val="C0504D"/>
+              <a:srgbClr val="B23A2E"/>
             </a:solidFill>
             <a:prstDash val="solid"/>
             <a:headEnd type="none"/>
@@ -3003,7 +2785,7 @@
       </p:sp>
       <p:sp>
         <p:nvSpPr>
-          <p:cNvPr id="37" name="Text 35"/>
+          <p:cNvPr id="38" name="Text 35"/>
           <p:cNvSpPr/>
           <p:nvPr/>
         </p:nvSpPr>
@@ -3028,7 +2810,7 @@
             <a:r>
               <a:rPr lang="en-US" sz="850" b="1" dirty="0">
                 <a:solidFill>
-                  <a:srgbClr val="2E7D32"/>
+                  <a:srgbClr val="1E8A80"/>
                 </a:solidFill>
                 <a:latin typeface="Calibri" pitchFamily="34" charset="0"/>
                 <a:ea typeface="Calibri" pitchFamily="34" charset="-122"/>
@@ -3042,7 +2824,7 @@
       </p:sp>
       <p:sp>
         <p:nvSpPr>
-          <p:cNvPr id="38" name="Shape 36"/>
+          <p:cNvPr id="39" name="Shape 36"/>
           <p:cNvSpPr/>
           <p:nvPr/>
         </p:nvSpPr>
@@ -3057,7 +2839,7 @@
             </a:avLst>
           </a:prstGeom>
           <a:solidFill>
-            <a:srgbClr val="F5B301"/>
+            <a:srgbClr val="1E8A80"/>
           </a:solidFill>
           <a:ln/>
           <a:effectLst>
@@ -3071,7 +2853,7 @@
       </p:sp>
       <p:sp>
         <p:nvSpPr>
-          <p:cNvPr id="39" name="Text 37"/>
+          <p:cNvPr id="40" name="Text 37"/>
           <p:cNvSpPr/>
           <p:nvPr/>
         </p:nvSpPr>
@@ -3096,7 +2878,7 @@
             <a:r>
               <a:rPr lang="en-US" sz="1050" b="1" dirty="0">
                 <a:solidFill>
-                  <a:srgbClr val="16305C"/>
+                  <a:srgbClr val="FFFFFF"/>
                 </a:solidFill>
                 <a:latin typeface="Calibri" pitchFamily="34" charset="0"/>
                 <a:ea typeface="Calibri" pitchFamily="34" charset="-122"/>
@@ -3110,7 +2892,7 @@
       </p:sp>
       <p:sp>
         <p:nvSpPr>
-          <p:cNvPr id="40" name="Text 38"/>
+          <p:cNvPr id="41" name="Text 38"/>
           <p:cNvSpPr/>
           <p:nvPr/>
         </p:nvSpPr>
@@ -3135,7 +2917,7 @@
             <a:r>
               <a:rPr lang="en-US" sz="800" i="1" dirty="0">
                 <a:solidFill>
-                  <a:srgbClr val="6B7480"/>
+                  <a:srgbClr val="5B6672"/>
                 </a:solidFill>
                 <a:latin typeface="Calibri" pitchFamily="34" charset="0"/>
                 <a:ea typeface="Calibri" pitchFamily="34" charset="-122"/>
@@ -3149,7 +2931,7 @@
       </p:sp>
       <p:sp>
         <p:nvSpPr>
-          <p:cNvPr id="41" name="Shape 39"/>
+          <p:cNvPr id="42" name="Shape 39"/>
           <p:cNvSpPr/>
           <p:nvPr/>
         </p:nvSpPr>
@@ -3183,7 +2965,7 @@
       </p:sp>
       <p:sp>
         <p:nvSpPr>
-          <p:cNvPr id="42" name="Text 40"/>
+          <p:cNvPr id="43" name="Text 40"/>
           <p:cNvSpPr/>
           <p:nvPr/>
         </p:nvSpPr>
@@ -3222,7 +3004,7 @@
       </p:sp>
       <p:sp>
         <p:nvSpPr>
-          <p:cNvPr id="43" name="Shape 41"/>
+          <p:cNvPr id="44" name="Shape 41"/>
           <p:cNvSpPr/>
           <p:nvPr/>
         </p:nvSpPr>
@@ -3256,7 +3038,7 @@
       </p:sp>
       <p:sp>
         <p:nvSpPr>
-          <p:cNvPr id="44" name="Text 42"/>
+          <p:cNvPr id="45" name="Text 42"/>
           <p:cNvSpPr/>
           <p:nvPr/>
         </p:nvSpPr>
@@ -3295,7 +3077,7 @@
       </p:sp>
       <p:sp>
         <p:nvSpPr>
-          <p:cNvPr id="45" name="Shape 43"/>
+          <p:cNvPr id="46" name="Shape 43"/>
           <p:cNvSpPr/>
           <p:nvPr/>
         </p:nvSpPr>
@@ -3329,7 +3111,7 @@
       </p:sp>
       <p:sp>
         <p:nvSpPr>
-          <p:cNvPr id="46" name="Text 44"/>
+          <p:cNvPr id="47" name="Text 44"/>
           <p:cNvSpPr/>
           <p:nvPr/>
         </p:nvSpPr>
@@ -3368,7 +3150,7 @@
       </p:sp>
       <p:sp>
         <p:nvSpPr>
-          <p:cNvPr id="47" name="Shape 45"/>
+          <p:cNvPr id="48" name="Shape 45"/>
           <p:cNvSpPr/>
           <p:nvPr/>
         </p:nvSpPr>
@@ -3383,7 +3165,7 @@
           <a:noFill/>
           <a:ln w="20320">
             <a:solidFill>
-              <a:srgbClr val="D99400"/>
+              <a:srgbClr val="1E8A80"/>
             </a:solidFill>
             <a:prstDash val="solid"/>
             <a:headEnd type="none"/>
@@ -3393,7 +3175,7 @@
       </p:sp>
       <p:sp>
         <p:nvSpPr>
-          <p:cNvPr id="48" name="Shape 46"/>
+          <p:cNvPr id="49" name="Shape 46"/>
           <p:cNvSpPr/>
           <p:nvPr/>
         </p:nvSpPr>
@@ -3408,7 +3190,7 @@
           <a:noFill/>
           <a:ln w="20320">
             <a:solidFill>
-              <a:srgbClr val="D99400"/>
+              <a:srgbClr val="1E8A80"/>
             </a:solidFill>
             <a:prstDash val="solid"/>
             <a:headEnd type="none"/>
@@ -3418,7 +3200,7 @@
       </p:sp>
       <p:sp>
         <p:nvSpPr>
-          <p:cNvPr id="49" name="Shape 47"/>
+          <p:cNvPr id="50" name="Shape 47"/>
           <p:cNvSpPr/>
           <p:nvPr/>
         </p:nvSpPr>
@@ -3433,7 +3215,7 @@
           <a:noFill/>
           <a:ln w="20320">
             <a:solidFill>
-              <a:srgbClr val="D99400"/>
+              <a:srgbClr val="1E8A80"/>
             </a:solidFill>
             <a:prstDash val="solid"/>
             <a:headEnd type="none"/>
@@ -3443,7 +3225,7 @@
       </p:sp>
       <p:sp>
         <p:nvSpPr>
-          <p:cNvPr id="50" name="Shape 48"/>
+          <p:cNvPr id="51" name="Shape 48"/>
           <p:cNvSpPr/>
           <p:nvPr/>
         </p:nvSpPr>
@@ -3458,7 +3240,7 @@
           <a:noFill/>
           <a:ln w="20320">
             <a:solidFill>
-              <a:srgbClr val="D99400"/>
+              <a:srgbClr val="1E8A80"/>
             </a:solidFill>
             <a:prstDash val="solid"/>
             <a:headEnd type="none"/>
@@ -3468,7 +3250,7 @@
       </p:sp>
       <p:sp>
         <p:nvSpPr>
-          <p:cNvPr id="51" name="Shape 49"/>
+          <p:cNvPr id="52" name="Shape 49"/>
           <p:cNvSpPr/>
           <p:nvPr/>
         </p:nvSpPr>
@@ -3481,11 +3263,11 @@
             <a:avLst/>
           </a:prstGeom>
           <a:solidFill>
-            <a:srgbClr val="DCE7F7"/>
+            <a:srgbClr val="D8ECE9"/>
           </a:solidFill>
           <a:ln w="12700">
             <a:solidFill>
-              <a:srgbClr val="2E6CC4"/>
+              <a:srgbClr val="1E8A80"/>
             </a:solidFill>
             <a:prstDash val="solid"/>
           </a:ln>
@@ -3500,7 +3282,7 @@
       </p:sp>
       <p:sp>
         <p:nvSpPr>
-          <p:cNvPr id="52" name="Text 50"/>
+          <p:cNvPr id="53" name="Text 50"/>
           <p:cNvSpPr/>
           <p:nvPr/>
         </p:nvSpPr>
@@ -3525,7 +3307,7 @@
             <a:r>
               <a:rPr lang="en-US" sz="900" b="1" dirty="0">
                 <a:solidFill>
-                  <a:srgbClr val="16305C"/>
+                  <a:srgbClr val="0D6665"/>
                 </a:solidFill>
                 <a:latin typeface="Calibri" pitchFamily="34" charset="0"/>
                 <a:ea typeface="Calibri" pitchFamily="34" charset="-122"/>
@@ -3539,7 +3321,7 @@
       </p:sp>
       <p:sp>
         <p:nvSpPr>
-          <p:cNvPr id="53" name="Text 51"/>
+          <p:cNvPr id="54" name="Text 51"/>
           <p:cNvSpPr/>
           <p:nvPr/>
         </p:nvSpPr>
@@ -3564,7 +3346,7 @@
             <a:r>
               <a:rPr lang="en-US" sz="850" b="1" dirty="0">
                 <a:solidFill>
-                  <a:srgbClr val="C0504D"/>
+                  <a:srgbClr val="B23A2E"/>
                 </a:solidFill>
                 <a:latin typeface="Calibri" pitchFamily="34" charset="0"/>
                 <a:ea typeface="Calibri" pitchFamily="34" charset="-122"/>
@@ -3578,7 +3360,7 @@
       </p:sp>
       <p:sp>
         <p:nvSpPr>
-          <p:cNvPr id="54" name="Shape 52"/>
+          <p:cNvPr id="55" name="Shape 52"/>
           <p:cNvSpPr/>
           <p:nvPr/>
         </p:nvSpPr>
@@ -3593,7 +3375,7 @@
           <a:noFill/>
           <a:ln w="17780">
             <a:solidFill>
-              <a:srgbClr val="C0504D"/>
+              <a:srgbClr val="B23A2E"/>
             </a:solidFill>
             <a:prstDash val="solid"/>
             <a:headEnd type="none"/>
@@ -3603,7 +3385,7 @@
       </p:sp>
       <p:sp>
         <p:nvSpPr>
-          <p:cNvPr id="55" name="Shape 53"/>
+          <p:cNvPr id="56" name="Shape 53"/>
           <p:cNvSpPr/>
           <p:nvPr/>
         </p:nvSpPr>
@@ -3618,11 +3400,11 @@
             </a:avLst>
           </a:prstGeom>
           <a:solidFill>
-            <a:srgbClr val="F4DAD8"/>
+            <a:srgbClr val="F3DBD7"/>
           </a:solidFill>
           <a:ln w="12700">
             <a:solidFill>
-              <a:srgbClr val="C0504D"/>
+              <a:srgbClr val="B23A2E"/>
             </a:solidFill>
             <a:prstDash val="solid"/>
           </a:ln>
@@ -3637,7 +3419,7 @@
       </p:sp>
       <p:sp>
         <p:nvSpPr>
-          <p:cNvPr id="56" name="Text 54"/>
+          <p:cNvPr id="57" name="Text 54"/>
           <p:cNvSpPr/>
           <p:nvPr/>
         </p:nvSpPr>
@@ -3662,7 +3444,7 @@
             <a:r>
               <a:rPr lang="en-US" sz="800" b="1" dirty="0">
                 <a:solidFill>
-                  <a:srgbClr val="C0504D"/>
+                  <a:srgbClr val="B23A2E"/>
                 </a:solidFill>
                 <a:latin typeface="Calibri" pitchFamily="34" charset="0"/>
                 <a:ea typeface="Calibri" pitchFamily="34" charset="-122"/>
@@ -3676,7 +3458,7 @@
       </p:sp>
       <p:sp>
         <p:nvSpPr>
-          <p:cNvPr id="57" name="Shape 55"/>
+          <p:cNvPr id="58" name="Shape 55"/>
           <p:cNvSpPr/>
           <p:nvPr/>
         </p:nvSpPr>
@@ -3691,7 +3473,7 @@
           <a:noFill/>
           <a:ln w="20320">
             <a:solidFill>
-              <a:srgbClr val="2E7D32"/>
+              <a:srgbClr val="1E8A80"/>
             </a:solidFill>
             <a:prstDash val="solid"/>
             <a:headEnd type="none"/>
@@ -3701,7 +3483,7 @@
       </p:sp>
       <p:sp>
         <p:nvSpPr>
-          <p:cNvPr id="58" name="Shape 56"/>
+          <p:cNvPr id="59" name="Shape 56"/>
           <p:cNvSpPr/>
           <p:nvPr/>
         </p:nvSpPr>
@@ -3716,7 +3498,7 @@
           <a:noFill/>
           <a:ln w="20320">
             <a:solidFill>
-              <a:srgbClr val="2E7D32"/>
+              <a:srgbClr val="1E8A80"/>
             </a:solidFill>
             <a:prstDash val="solid"/>
             <a:headEnd type="none"/>
@@ -3726,7 +3508,7 @@
       </p:sp>
       <p:sp>
         <p:nvSpPr>
-          <p:cNvPr id="59" name="Shape 57"/>
+          <p:cNvPr id="60" name="Shape 57"/>
           <p:cNvSpPr/>
           <p:nvPr/>
         </p:nvSpPr>
@@ -3741,7 +3523,7 @@
           <a:noFill/>
           <a:ln w="20320">
             <a:solidFill>
-              <a:srgbClr val="2E7D32"/>
+              <a:srgbClr val="1E8A80"/>
             </a:solidFill>
             <a:prstDash val="solid"/>
             <a:headEnd type="none"/>
@@ -3751,7 +3533,7 @@
       </p:sp>
       <p:sp>
         <p:nvSpPr>
-          <p:cNvPr id="60" name="Text 58"/>
+          <p:cNvPr id="61" name="Text 58"/>
           <p:cNvSpPr/>
           <p:nvPr/>
         </p:nvSpPr>
@@ -3776,7 +3558,7 @@
             <a:r>
               <a:rPr lang="en-US" sz="850" b="1" dirty="0">
                 <a:solidFill>
-                  <a:srgbClr val="2E7D32"/>
+                  <a:srgbClr val="1E8A80"/>
                 </a:solidFill>
                 <a:latin typeface="Calibri" pitchFamily="34" charset="0"/>
                 <a:ea typeface="Calibri" pitchFamily="34" charset="-122"/>
@@ -3790,7 +3572,7 @@
       </p:sp>
       <p:sp>
         <p:nvSpPr>
-          <p:cNvPr id="61" name="Shape 59"/>
+          <p:cNvPr id="62" name="Shape 59"/>
           <p:cNvSpPr/>
           <p:nvPr/>
         </p:nvSpPr>
@@ -3819,7 +3601,7 @@
       </p:sp>
       <p:sp>
         <p:nvSpPr>
-          <p:cNvPr id="62" name="Shape 60"/>
+          <p:cNvPr id="63" name="Shape 60"/>
           <p:cNvSpPr/>
           <p:nvPr/>
         </p:nvSpPr>
@@ -3832,14 +3614,14 @@
             <a:avLst/>
           </a:prstGeom>
           <a:solidFill>
-            <a:srgbClr val="1F4E9B"/>
-          </a:solidFill>
-          <a:ln/>
-        </p:spPr>
-      </p:sp>
-      <p:sp>
-        <p:nvSpPr>
-          <p:cNvPr id="63" name="Shape 61"/>
+            <a:srgbClr val="22346B"/>
+          </a:solidFill>
+          <a:ln/>
+        </p:spPr>
+      </p:sp>
+      <p:sp>
+        <p:nvSpPr>
+          <p:cNvPr id="64" name="Shape 61"/>
           <p:cNvSpPr/>
           <p:nvPr/>
         </p:nvSpPr>
@@ -3852,7 +3634,7 @@
             <a:avLst/>
           </a:prstGeom>
           <a:solidFill>
-            <a:srgbClr val="1F4E9B"/>
+            <a:srgbClr val="22346B"/>
           </a:solidFill>
           <a:ln/>
           <a:effectLst>
@@ -3866,7 +3648,7 @@
       </p:sp>
       <p:sp>
         <p:nvSpPr>
-          <p:cNvPr id="64" name="Text 62"/>
+          <p:cNvPr id="65" name="Text 62"/>
           <p:cNvSpPr/>
           <p:nvPr/>
         </p:nvSpPr>
@@ -3905,7 +3687,7 @@
       </p:sp>
       <p:sp>
         <p:nvSpPr>
-          <p:cNvPr id="65" name="Text 63"/>
+          <p:cNvPr id="66" name="Text 63"/>
           <p:cNvSpPr/>
           <p:nvPr/>
         </p:nvSpPr>
@@ -3933,7 +3715,7 @@
             <a:r>
               <a:rPr lang="en-US" sz="1150" b="1" dirty="0">
                 <a:solidFill>
-                  <a:srgbClr val="16305C"/>
+                  <a:srgbClr val="22346B"/>
                 </a:solidFill>
                 <a:latin typeface="Calibri" pitchFamily="34" charset="0"/>
                 <a:ea typeface="Calibri" pitchFamily="34" charset="-122"/>
@@ -3953,7 +3735,7 @@
             <a:r>
               <a:rPr lang="en-US" sz="800" dirty="0">
                 <a:solidFill>
-                  <a:srgbClr val="6B7480"/>
+                  <a:srgbClr val="5B6672"/>
                 </a:solidFill>
                 <a:latin typeface="Calibri" pitchFamily="34" charset="0"/>
                 <a:ea typeface="Calibri" pitchFamily="34" charset="-122"/>
@@ -3973,7 +3755,7 @@
             <a:r>
               <a:rPr lang="en-US" sz="800" dirty="0">
                 <a:solidFill>
-                  <a:srgbClr val="6B7480"/>
+                  <a:srgbClr val="5B6672"/>
                 </a:solidFill>
                 <a:latin typeface="Calibri" pitchFamily="34" charset="0"/>
                 <a:ea typeface="Calibri" pitchFamily="34" charset="-122"/>
@@ -3987,7 +3769,7 @@
       </p:sp>
       <p:sp>
         <p:nvSpPr>
-          <p:cNvPr id="66" name="Shape 64"/>
+          <p:cNvPr id="67" name="Shape 64"/>
           <p:cNvSpPr/>
           <p:nvPr/>
         </p:nvSpPr>
@@ -4002,7 +3784,7 @@
           <a:noFill/>
           <a:ln w="20320">
             <a:solidFill>
-              <a:srgbClr val="2E7D32"/>
+              <a:srgbClr val="1E8A80"/>
             </a:solidFill>
             <a:prstDash val="solid"/>
             <a:headEnd type="none"/>
@@ -4012,7 +3794,7 @@
       </p:sp>
       <p:sp>
         <p:nvSpPr>
-          <p:cNvPr id="67" name="Shape 65"/>
+          <p:cNvPr id="68" name="Shape 65"/>
           <p:cNvSpPr/>
           <p:nvPr/>
         </p:nvSpPr>
@@ -4027,7 +3809,7 @@
           <a:noFill/>
           <a:ln w="20320">
             <a:solidFill>
-              <a:srgbClr val="2E7D32"/>
+              <a:srgbClr val="1E8A80"/>
             </a:solidFill>
             <a:prstDash val="solid"/>
             <a:headEnd type="none"/>
@@ -4037,7 +3819,7 @@
       </p:sp>
       <p:sp>
         <p:nvSpPr>
-          <p:cNvPr id="68" name="Shape 66"/>
+          <p:cNvPr id="69" name="Shape 66"/>
           <p:cNvSpPr/>
           <p:nvPr/>
         </p:nvSpPr>
@@ -4052,7 +3834,7 @@
           <a:noFill/>
           <a:ln w="20320">
             <a:solidFill>
-              <a:srgbClr val="2E7D32"/>
+              <a:srgbClr val="1E8A80"/>
             </a:solidFill>
             <a:prstDash val="solid"/>
             <a:headEnd type="none"/>
@@ -4062,7 +3844,7 @@
       </p:sp>
       <p:sp>
         <p:nvSpPr>
-          <p:cNvPr id="69" name="Shape 67"/>
+          <p:cNvPr id="70" name="Shape 67"/>
           <p:cNvSpPr/>
           <p:nvPr/>
         </p:nvSpPr>
@@ -4077,7 +3859,7 @@
           <a:noFill/>
           <a:ln w="22860">
             <a:solidFill>
-              <a:srgbClr val="2E6CC4"/>
+              <a:srgbClr val="34528A"/>
             </a:solidFill>
             <a:prstDash val="solid"/>
             <a:headEnd type="none"/>
@@ -4087,7 +3869,7 @@
       </p:sp>
       <p:sp>
         <p:nvSpPr>
-          <p:cNvPr id="70" name="Shape 68"/>
+          <p:cNvPr id="71" name="Shape 68"/>
           <p:cNvSpPr/>
           <p:nvPr/>
         </p:nvSpPr>
@@ -4100,11 +3882,11 @@
             <a:avLst/>
           </a:prstGeom>
           <a:solidFill>
-            <a:srgbClr val="F5B301"/>
+            <a:srgbClr val="E45D4A"/>
           </a:solidFill>
           <a:ln w="12700">
             <a:solidFill>
-              <a:srgbClr val="D99400"/>
+              <a:srgbClr val="C0402F"/>
             </a:solidFill>
             <a:prstDash val="solid"/>
           </a:ln>
@@ -4119,7 +3901,7 @@
       </p:sp>
       <p:sp>
         <p:nvSpPr>
-          <p:cNvPr id="71" name="Text 69"/>
+          <p:cNvPr id="72" name="Text 69"/>
           <p:cNvSpPr/>
           <p:nvPr/>
         </p:nvSpPr>
@@ -4144,7 +3926,7 @@
             <a:r>
               <a:rPr lang="en-US" sz="900" b="1" dirty="0">
                 <a:solidFill>
-                  <a:srgbClr val="16305C"/>
+                  <a:srgbClr val="22346B"/>
                 </a:solidFill>
                 <a:latin typeface="Calibri" pitchFamily="34" charset="0"/>
                 <a:ea typeface="Calibri" pitchFamily="34" charset="-122"/>
@@ -4161,7 +3943,7 @@
             <a:r>
               <a:rPr lang="en-US" sz="900" b="1" dirty="0">
                 <a:solidFill>
-                  <a:srgbClr val="16305C"/>
+                  <a:srgbClr val="22346B"/>
                 </a:solidFill>
                 <a:latin typeface="Calibri" pitchFamily="34" charset="0"/>
                 <a:ea typeface="Calibri" pitchFamily="34" charset="-122"/>
@@ -4175,7 +3957,7 @@
       </p:sp>
       <p:sp>
         <p:nvSpPr>
-          <p:cNvPr id="72" name="Text 70"/>
+          <p:cNvPr id="73" name="Text 70"/>
           <p:cNvSpPr/>
           <p:nvPr/>
         </p:nvSpPr>
@@ -4200,7 +3982,7 @@
             <a:r>
               <a:rPr lang="en-US" sz="850" b="1" dirty="0">
                 <a:solidFill>
-                  <a:srgbClr val="C0504D"/>
+                  <a:srgbClr val="B23A2E"/>
                 </a:solidFill>
                 <a:latin typeface="Calibri" pitchFamily="34" charset="0"/>
                 <a:ea typeface="Calibri" pitchFamily="34" charset="-122"/>
@@ -4214,7 +3996,7 @@
       </p:sp>
       <p:sp>
         <p:nvSpPr>
-          <p:cNvPr id="73" name="Shape 71"/>
+          <p:cNvPr id="74" name="Shape 71"/>
           <p:cNvSpPr/>
           <p:nvPr/>
         </p:nvSpPr>
@@ -4229,7 +4011,7 @@
           <a:noFill/>
           <a:ln w="17780">
             <a:solidFill>
-              <a:srgbClr val="C0504D"/>
+              <a:srgbClr val="B23A2E"/>
             </a:solidFill>
             <a:prstDash val="solid"/>
             <a:headEnd type="none"/>
@@ -4239,7 +4021,7 @@
       </p:sp>
       <p:sp>
         <p:nvSpPr>
-          <p:cNvPr id="74" name="Shape 72"/>
+          <p:cNvPr id="75" name="Shape 72"/>
           <p:cNvSpPr/>
           <p:nvPr/>
         </p:nvSpPr>
@@ -4254,7 +4036,7 @@
           <a:noFill/>
           <a:ln w="17780">
             <a:solidFill>
-              <a:srgbClr val="C0504D"/>
+              <a:srgbClr val="B23A2E"/>
             </a:solidFill>
             <a:prstDash val="solid"/>
             <a:headEnd type="none"/>
@@ -4264,7 +4046,7 @@
       </p:sp>
       <p:sp>
         <p:nvSpPr>
-          <p:cNvPr id="75" name="Shape 73"/>
+          <p:cNvPr id="76" name="Shape 73"/>
           <p:cNvSpPr/>
           <p:nvPr/>
         </p:nvSpPr>
@@ -4279,7 +4061,7 @@
           <a:noFill/>
           <a:ln w="17780">
             <a:solidFill>
-              <a:srgbClr val="C0504D"/>
+              <a:srgbClr val="B23A2E"/>
             </a:solidFill>
             <a:prstDash val="solid"/>
             <a:headEnd type="none"/>
@@ -4289,7 +4071,7 @@
       </p:sp>
       <p:sp>
         <p:nvSpPr>
-          <p:cNvPr id="76" name="Shape 74"/>
+          <p:cNvPr id="77" name="Shape 74"/>
           <p:cNvSpPr/>
           <p:nvPr/>
         </p:nvSpPr>
@@ -4304,11 +4086,11 @@
             </a:avLst>
           </a:prstGeom>
           <a:solidFill>
-            <a:srgbClr val="F4DAD8"/>
+            <a:srgbClr val="F3DBD7"/>
           </a:solidFill>
           <a:ln w="12700">
             <a:solidFill>
-              <a:srgbClr val="C0504D"/>
+              <a:srgbClr val="B23A2E"/>
             </a:solidFill>
             <a:prstDash val="solid"/>
           </a:ln>
@@ -4323,7 +4105,7 @@
       </p:sp>
       <p:sp>
         <p:nvSpPr>
-          <p:cNvPr id="77" name="Text 75"/>
+          <p:cNvPr id="78" name="Text 75"/>
           <p:cNvSpPr/>
           <p:nvPr/>
         </p:nvSpPr>
@@ -4348,7 +4130,7 @@
             <a:r>
               <a:rPr lang="en-US" sz="800" b="1" dirty="0">
                 <a:solidFill>
-                  <a:srgbClr val="C0504D"/>
+                  <a:srgbClr val="B23A2E"/>
                 </a:solidFill>
                 <a:latin typeface="Calibri" pitchFamily="34" charset="0"/>
                 <a:ea typeface="Calibri" pitchFamily="34" charset="-122"/>
@@ -4362,7 +4144,7 @@
       </p:sp>
       <p:sp>
         <p:nvSpPr>
-          <p:cNvPr id="78" name="Text 76"/>
+          <p:cNvPr id="79" name="Text 76"/>
           <p:cNvSpPr/>
           <p:nvPr/>
         </p:nvSpPr>
@@ -4387,7 +4169,7 @@
             <a:r>
               <a:rPr lang="en-US" sz="850" b="1" dirty="0">
                 <a:solidFill>
-                  <a:srgbClr val="2E7D32"/>
+                  <a:srgbClr val="1E8A80"/>
                 </a:solidFill>
                 <a:latin typeface="Calibri" pitchFamily="34" charset="0"/>
                 <a:ea typeface="Calibri" pitchFamily="34" charset="-122"/>
@@ -4401,7 +4183,7 @@
       </p:sp>
       <p:sp>
         <p:nvSpPr>
-          <p:cNvPr id="79" name="Shape 77"/>
+          <p:cNvPr id="80" name="Shape 77"/>
           <p:cNvSpPr/>
           <p:nvPr/>
         </p:nvSpPr>
@@ -4430,7 +4212,7 @@
       </p:sp>
       <p:sp>
         <p:nvSpPr>
-          <p:cNvPr id="80" name="Shape 78"/>
+          <p:cNvPr id="81" name="Shape 78"/>
           <p:cNvSpPr/>
           <p:nvPr/>
         </p:nvSpPr>
@@ -4443,14 +4225,14 @@
             <a:avLst/>
           </a:prstGeom>
           <a:solidFill>
-            <a:srgbClr val="D99400"/>
-          </a:solidFill>
-          <a:ln/>
-        </p:spPr>
-      </p:sp>
-      <p:sp>
-        <p:nvSpPr>
-          <p:cNvPr id="81" name="Shape 79"/>
+            <a:srgbClr val="C0402F"/>
+          </a:solidFill>
+          <a:ln/>
+        </p:spPr>
+      </p:sp>
+      <p:sp>
+        <p:nvSpPr>
+          <p:cNvPr id="82" name="Shape 79"/>
           <p:cNvSpPr/>
           <p:nvPr/>
         </p:nvSpPr>
@@ -4463,7 +4245,7 @@
             <a:avLst/>
           </a:prstGeom>
           <a:solidFill>
-            <a:srgbClr val="D99400"/>
+            <a:srgbClr val="C0402F"/>
           </a:solidFill>
           <a:ln/>
           <a:effectLst>
@@ -4477,7 +4259,7 @@
       </p:sp>
       <p:sp>
         <p:nvSpPr>
-          <p:cNvPr id="82" name="Text 80"/>
+          <p:cNvPr id="83" name="Text 80"/>
           <p:cNvSpPr/>
           <p:nvPr/>
         </p:nvSpPr>
@@ -4516,7 +4298,7 @@
       </p:sp>
       <p:sp>
         <p:nvSpPr>
-          <p:cNvPr id="83" name="Text 81"/>
+          <p:cNvPr id="84" name="Text 81"/>
           <p:cNvSpPr/>
           <p:nvPr/>
         </p:nvSpPr>
@@ -4544,7 +4326,7 @@
             <a:r>
               <a:rPr lang="en-US" sz="1150" b="1" dirty="0">
                 <a:solidFill>
-                  <a:srgbClr val="16305C"/>
+                  <a:srgbClr val="22346B"/>
                 </a:solidFill>
                 <a:latin typeface="Calibri" pitchFamily="34" charset="0"/>
                 <a:ea typeface="Calibri" pitchFamily="34" charset="-122"/>
@@ -4564,7 +4346,7 @@
             <a:r>
               <a:rPr lang="en-US" sz="800" dirty="0">
                 <a:solidFill>
-                  <a:srgbClr val="6B7480"/>
+                  <a:srgbClr val="5B6672"/>
                 </a:solidFill>
                 <a:latin typeface="Calibri" pitchFamily="34" charset="0"/>
                 <a:ea typeface="Calibri" pitchFamily="34" charset="-122"/>
@@ -4584,7 +4366,7 @@
             <a:r>
               <a:rPr lang="en-US" sz="800" dirty="0">
                 <a:solidFill>
-                  <a:srgbClr val="6B7480"/>
+                  <a:srgbClr val="5B6672"/>
                 </a:solidFill>
                 <a:latin typeface="Calibri" pitchFamily="34" charset="0"/>
                 <a:ea typeface="Calibri" pitchFamily="34" charset="-122"/>
@@ -4598,7 +4380,7 @@
       </p:sp>
       <p:sp>
         <p:nvSpPr>
-          <p:cNvPr id="84" name="Shape 82"/>
+          <p:cNvPr id="85" name="Shape 82"/>
           <p:cNvSpPr/>
           <p:nvPr/>
         </p:nvSpPr>
@@ -4613,7 +4395,7 @@
           <a:noFill/>
           <a:ln w="22860">
             <a:solidFill>
-              <a:srgbClr val="2E6CC4"/>
+              <a:srgbClr val="34528A"/>
             </a:solidFill>
             <a:prstDash val="solid"/>
             <a:headEnd type="none"/>
@@ -4623,7 +4405,7 @@
       </p:sp>
       <p:sp>
         <p:nvSpPr>
-          <p:cNvPr id="85" name="Shape 83"/>
+          <p:cNvPr id="86" name="Shape 83"/>
           <p:cNvSpPr/>
           <p:nvPr/>
         </p:nvSpPr>
@@ -4652,7 +4434,7 @@
       </p:sp>
       <p:sp>
         <p:nvSpPr>
-          <p:cNvPr id="86" name="Shape 84"/>
+          <p:cNvPr id="87" name="Shape 84"/>
           <p:cNvSpPr/>
           <p:nvPr/>
         </p:nvSpPr>
@@ -4665,14 +4447,14 @@
             <a:avLst/>
           </a:prstGeom>
           <a:solidFill>
-            <a:srgbClr val="1F4E9B"/>
-          </a:solidFill>
-          <a:ln/>
-        </p:spPr>
-      </p:sp>
-      <p:sp>
-        <p:nvSpPr>
-          <p:cNvPr id="87" name="Shape 85"/>
+            <a:srgbClr val="22346B"/>
+          </a:solidFill>
+          <a:ln/>
+        </p:spPr>
+      </p:sp>
+      <p:sp>
+        <p:nvSpPr>
+          <p:cNvPr id="88" name="Shape 85"/>
           <p:cNvSpPr/>
           <p:nvPr/>
         </p:nvSpPr>
@@ -4685,7 +4467,7 @@
             <a:avLst/>
           </a:prstGeom>
           <a:solidFill>
-            <a:srgbClr val="1F4E9B"/>
+            <a:srgbClr val="22346B"/>
           </a:solidFill>
           <a:ln/>
           <a:effectLst>
@@ -4699,7 +4481,7 @@
       </p:sp>
       <p:sp>
         <p:nvSpPr>
-          <p:cNvPr id="88" name="Text 86"/>
+          <p:cNvPr id="89" name="Text 86"/>
           <p:cNvSpPr/>
           <p:nvPr/>
         </p:nvSpPr>
@@ -4738,7 +4520,7 @@
       </p:sp>
       <p:sp>
         <p:nvSpPr>
-          <p:cNvPr id="89" name="Text 87"/>
+          <p:cNvPr id="90" name="Text 87"/>
           <p:cNvSpPr/>
           <p:nvPr/>
         </p:nvSpPr>
@@ -4766,7 +4548,7 @@
             <a:r>
               <a:rPr lang="en-US" sz="1150" b="1" dirty="0">
                 <a:solidFill>
-                  <a:srgbClr val="16305C"/>
+                  <a:srgbClr val="22346B"/>
                 </a:solidFill>
                 <a:latin typeface="Calibri" pitchFamily="34" charset="0"/>
                 <a:ea typeface="Calibri" pitchFamily="34" charset="-122"/>
@@ -4786,7 +4568,7 @@
             <a:r>
               <a:rPr lang="en-US" sz="800" dirty="0">
                 <a:solidFill>
-                  <a:srgbClr val="6B7480"/>
+                  <a:srgbClr val="5B6672"/>
                 </a:solidFill>
                 <a:latin typeface="Calibri" pitchFamily="34" charset="0"/>
                 <a:ea typeface="Calibri" pitchFamily="34" charset="-122"/>
@@ -4806,7 +4588,7 @@
             <a:r>
               <a:rPr lang="en-US" sz="800" dirty="0">
                 <a:solidFill>
-                  <a:srgbClr val="6B7480"/>
+                  <a:srgbClr val="5B6672"/>
                 </a:solidFill>
                 <a:latin typeface="Calibri" pitchFamily="34" charset="0"/>
                 <a:ea typeface="Calibri" pitchFamily="34" charset="-122"/>
@@ -4826,7 +4608,7 @@
             <a:r>
               <a:rPr lang="en-US" sz="800" dirty="0">
                 <a:solidFill>
-                  <a:srgbClr val="6B7480"/>
+                  <a:srgbClr val="5B6672"/>
                 </a:solidFill>
                 <a:latin typeface="Calibri" pitchFamily="34" charset="0"/>
                 <a:ea typeface="Calibri" pitchFamily="34" charset="-122"/>
@@ -4840,7 +4622,7 @@
       </p:sp>
       <p:sp>
         <p:nvSpPr>
-          <p:cNvPr id="90" name="Shape 88"/>
+          <p:cNvPr id="91" name="Shape 88"/>
           <p:cNvSpPr/>
           <p:nvPr/>
         </p:nvSpPr>
@@ -4855,7 +4637,7 @@
           <a:noFill/>
           <a:ln w="22860">
             <a:solidFill>
-              <a:srgbClr val="2E6CC4"/>
+              <a:srgbClr val="34528A"/>
             </a:solidFill>
             <a:prstDash val="solid"/>
             <a:headEnd type="none"/>
@@ -4865,7 +4647,7 @@
       </p:sp>
       <p:sp>
         <p:nvSpPr>
-          <p:cNvPr id="91" name="Shape 89"/>
+          <p:cNvPr id="92" name="Shape 89"/>
           <p:cNvSpPr/>
           <p:nvPr/>
         </p:nvSpPr>
@@ -4880,7 +4662,7 @@
             </a:avLst>
           </a:prstGeom>
           <a:solidFill>
-            <a:srgbClr val="EAF5EC"/>
+            <a:srgbClr val="DCEEEA"/>
           </a:solidFill>
           <a:ln/>
           <a:effectLst>
@@ -4894,7 +4676,7 @@
       </p:sp>
       <p:sp>
         <p:nvSpPr>
-          <p:cNvPr id="92" name="Shape 90"/>
+          <p:cNvPr id="93" name="Shape 90"/>
           <p:cNvSpPr/>
           <p:nvPr/>
         </p:nvSpPr>
@@ -4907,14 +4689,14 @@
             <a:avLst/>
           </a:prstGeom>
           <a:solidFill>
-            <a:srgbClr val="2E7D32"/>
-          </a:solidFill>
-          <a:ln/>
-        </p:spPr>
-      </p:sp>
-      <p:sp>
-        <p:nvSpPr>
-          <p:cNvPr id="93" name="Shape 91"/>
+            <a:srgbClr val="1E8A80"/>
+          </a:solidFill>
+          <a:ln/>
+        </p:spPr>
+      </p:sp>
+      <p:sp>
+        <p:nvSpPr>
+          <p:cNvPr id="94" name="Shape 91"/>
           <p:cNvSpPr/>
           <p:nvPr/>
         </p:nvSpPr>
@@ -4927,7 +4709,7 @@
             <a:avLst/>
           </a:prstGeom>
           <a:solidFill>
-            <a:srgbClr val="2E7D32"/>
+            <a:srgbClr val="1E8A80"/>
           </a:solidFill>
           <a:ln/>
           <a:effectLst>
@@ -4941,7 +4723,7 @@
       </p:sp>
       <p:sp>
         <p:nvSpPr>
-          <p:cNvPr id="94" name="Text 92"/>
+          <p:cNvPr id="95" name="Text 92"/>
           <p:cNvSpPr/>
           <p:nvPr/>
         </p:nvSpPr>
@@ -4980,7 +4762,7 @@
       </p:sp>
       <p:sp>
         <p:nvSpPr>
-          <p:cNvPr id="95" name="Text 93"/>
+          <p:cNvPr id="96" name="Text 93"/>
           <p:cNvSpPr/>
           <p:nvPr/>
         </p:nvSpPr>
@@ -5008,7 +4790,7 @@
             <a:r>
               <a:rPr lang="en-US" sz="1150" b="1" dirty="0">
                 <a:solidFill>
-                  <a:srgbClr val="1B5E20"/>
+                  <a:srgbClr val="0D6665"/>
                 </a:solidFill>
                 <a:latin typeface="Calibri" pitchFamily="34" charset="0"/>
                 <a:ea typeface="Calibri" pitchFamily="34" charset="-122"/>
@@ -5028,7 +4810,7 @@
             <a:r>
               <a:rPr lang="en-US" sz="800" dirty="0">
                 <a:solidFill>
-                  <a:srgbClr val="6B7480"/>
+                  <a:srgbClr val="5B6672"/>
                 </a:solidFill>
                 <a:latin typeface="Calibri" pitchFamily="34" charset="0"/>
                 <a:ea typeface="Calibri" pitchFamily="34" charset="-122"/>
@@ -5048,7 +4830,7 @@
             <a:r>
               <a:rPr lang="en-US" sz="800" dirty="0">
                 <a:solidFill>
-                  <a:srgbClr val="6B7480"/>
+                  <a:srgbClr val="5B6672"/>
                 </a:solidFill>
                 <a:latin typeface="Calibri" pitchFamily="34" charset="0"/>
                 <a:ea typeface="Calibri" pitchFamily="34" charset="-122"/>
@@ -5062,7 +4844,7 @@
       </p:sp>
       <p:sp>
         <p:nvSpPr>
-          <p:cNvPr id="96" name="Shape 94"/>
+          <p:cNvPr id="97" name="Shape 94"/>
           <p:cNvSpPr/>
           <p:nvPr/>
         </p:nvSpPr>
@@ -5077,7 +4859,7 @@
           <a:noFill/>
           <a:ln w="22860">
             <a:solidFill>
-              <a:srgbClr val="2E7D32"/>
+              <a:srgbClr val="1E8A80"/>
             </a:solidFill>
             <a:prstDash val="solid"/>
             <a:headEnd type="none"/>
@@ -5087,7 +4869,7 @@
       </p:sp>
       <p:sp>
         <p:nvSpPr>
-          <p:cNvPr id="97" name="Shape 95"/>
+          <p:cNvPr id="98" name="Shape 95"/>
           <p:cNvSpPr/>
           <p:nvPr/>
         </p:nvSpPr>
@@ -5116,7 +4898,7 @@
       </p:sp>
       <p:sp>
         <p:nvSpPr>
-          <p:cNvPr id="98" name="Shape 96"/>
+          <p:cNvPr id="99" name="Shape 96"/>
           <p:cNvSpPr/>
           <p:nvPr/>
         </p:nvSpPr>
@@ -5131,14 +4913,14 @@
             </a:avLst>
           </a:prstGeom>
           <a:solidFill>
-            <a:srgbClr val="1F4E9B"/>
-          </a:solidFill>
-          <a:ln/>
-        </p:spPr>
-      </p:sp>
-      <p:sp>
-        <p:nvSpPr>
-          <p:cNvPr id="99" name="Shape 97"/>
+            <a:srgbClr val="22346B"/>
+          </a:solidFill>
+          <a:ln/>
+        </p:spPr>
+      </p:sp>
+      <p:sp>
+        <p:nvSpPr>
+          <p:cNvPr id="100" name="Shape 97"/>
           <p:cNvSpPr/>
           <p:nvPr/>
         </p:nvSpPr>
@@ -5151,14 +4933,14 @@
             <a:avLst/>
           </a:prstGeom>
           <a:solidFill>
-            <a:srgbClr val="1F4E9B"/>
-          </a:solidFill>
-          <a:ln/>
-        </p:spPr>
-      </p:sp>
-      <p:sp>
-        <p:nvSpPr>
-          <p:cNvPr id="100" name="Shape 98"/>
+            <a:srgbClr val="22346B"/>
+          </a:solidFill>
+          <a:ln/>
+        </p:spPr>
+      </p:sp>
+      <p:sp>
+        <p:nvSpPr>
+          <p:cNvPr id="101" name="Shape 98"/>
           <p:cNvSpPr/>
           <p:nvPr/>
         </p:nvSpPr>
@@ -5171,14 +4953,14 @@
             <a:avLst/>
           </a:prstGeom>
           <a:solidFill>
-            <a:srgbClr val="F5B301"/>
-          </a:solidFill>
-          <a:ln/>
-        </p:spPr>
-      </p:sp>
-      <p:sp>
-        <p:nvSpPr>
-          <p:cNvPr id="101" name="Text 99"/>
+            <a:srgbClr val="E45D4A"/>
+          </a:solidFill>
+          <a:ln/>
+        </p:spPr>
+      </p:sp>
+      <p:sp>
+        <p:nvSpPr>
+          <p:cNvPr id="102" name="Text 99"/>
           <p:cNvSpPr/>
           <p:nvPr/>
         </p:nvSpPr>
@@ -5217,7 +4999,7 @@
       </p:sp>
       <p:sp>
         <p:nvSpPr>
-          <p:cNvPr id="102" name="Text 100"/>
+          <p:cNvPr id="103" name="Text 100"/>
           <p:cNvSpPr/>
           <p:nvPr/>
         </p:nvSpPr>
@@ -5400,7 +5182,7 @@
       </p:sp>
       <p:sp>
         <p:nvSpPr>
-          <p:cNvPr id="103" name="Shape 101"/>
+          <p:cNvPr id="104" name="Shape 101"/>
           <p:cNvSpPr/>
           <p:nvPr/>
         </p:nvSpPr>
@@ -5429,7 +5211,7 @@
       </p:sp>
       <p:sp>
         <p:nvSpPr>
-          <p:cNvPr id="104" name="Shape 102"/>
+          <p:cNvPr id="105" name="Shape 102"/>
           <p:cNvSpPr/>
           <p:nvPr/>
         </p:nvSpPr>
@@ -5444,14 +5226,14 @@
             </a:avLst>
           </a:prstGeom>
           <a:solidFill>
-            <a:srgbClr val="1F4E9B"/>
-          </a:solidFill>
-          <a:ln/>
-        </p:spPr>
-      </p:sp>
-      <p:sp>
-        <p:nvSpPr>
-          <p:cNvPr id="105" name="Shape 103"/>
+            <a:srgbClr val="E45D4A"/>
+          </a:solidFill>
+          <a:ln/>
+        </p:spPr>
+      </p:sp>
+      <p:sp>
+        <p:nvSpPr>
+          <p:cNvPr id="106" name="Shape 103"/>
           <p:cNvSpPr/>
           <p:nvPr/>
         </p:nvSpPr>
@@ -5464,14 +5246,14 @@
             <a:avLst/>
           </a:prstGeom>
           <a:solidFill>
-            <a:srgbClr val="1F4E9B"/>
-          </a:solidFill>
-          <a:ln/>
-        </p:spPr>
-      </p:sp>
-      <p:sp>
-        <p:nvSpPr>
-          <p:cNvPr id="106" name="Shape 104"/>
+            <a:srgbClr val="E45D4A"/>
+          </a:solidFill>
+          <a:ln/>
+        </p:spPr>
+      </p:sp>
+      <p:sp>
+        <p:nvSpPr>
+          <p:cNvPr id="107" name="Shape 104"/>
           <p:cNvSpPr/>
           <p:nvPr/>
         </p:nvSpPr>
@@ -5484,14 +5266,14 @@
             <a:avLst/>
           </a:prstGeom>
           <a:solidFill>
-            <a:srgbClr val="F5B301"/>
-          </a:solidFill>
-          <a:ln/>
-        </p:spPr>
-      </p:sp>
-      <p:sp>
-        <p:nvSpPr>
-          <p:cNvPr id="107" name="Text 105"/>
+            <a:srgbClr val="E45D4A"/>
+          </a:solidFill>
+          <a:ln/>
+        </p:spPr>
+      </p:sp>
+      <p:sp>
+        <p:nvSpPr>
+          <p:cNvPr id="108" name="Text 105"/>
           <p:cNvSpPr/>
           <p:nvPr/>
         </p:nvSpPr>
@@ -5530,7 +5312,7 @@
       </p:sp>
       <p:sp>
         <p:nvSpPr>
-          <p:cNvPr id="108" name="Text 106"/>
+          <p:cNvPr id="109" name="Text 106"/>
           <p:cNvSpPr/>
           <p:nvPr/>
         </p:nvSpPr>
@@ -5690,7 +5472,7 @@
       </p:sp>
       <p:sp>
         <p:nvSpPr>
-          <p:cNvPr id="109" name="Shape 107"/>
+          <p:cNvPr id="110" name="Shape 107"/>
           <p:cNvSpPr/>
           <p:nvPr/>
         </p:nvSpPr>
@@ -5719,7 +5501,7 @@
       </p:sp>
       <p:sp>
         <p:nvSpPr>
-          <p:cNvPr id="110" name="Shape 108"/>
+          <p:cNvPr id="111" name="Shape 108"/>
           <p:cNvSpPr/>
           <p:nvPr/>
         </p:nvSpPr>
@@ -5734,14 +5516,14 @@
             </a:avLst>
           </a:prstGeom>
           <a:solidFill>
-            <a:srgbClr val="C0504D"/>
-          </a:solidFill>
-          <a:ln/>
-        </p:spPr>
-      </p:sp>
-      <p:sp>
-        <p:nvSpPr>
-          <p:cNvPr id="111" name="Shape 109"/>
+            <a:srgbClr val="B23A2E"/>
+          </a:solidFill>
+          <a:ln/>
+        </p:spPr>
+      </p:sp>
+      <p:sp>
+        <p:nvSpPr>
+          <p:cNvPr id="112" name="Shape 109"/>
           <p:cNvSpPr/>
           <p:nvPr/>
         </p:nvSpPr>
@@ -5754,14 +5536,14 @@
             <a:avLst/>
           </a:prstGeom>
           <a:solidFill>
-            <a:srgbClr val="C0504D"/>
-          </a:solidFill>
-          <a:ln/>
-        </p:spPr>
-      </p:sp>
-      <p:sp>
-        <p:nvSpPr>
-          <p:cNvPr id="112" name="Shape 110"/>
+            <a:srgbClr val="B23A2E"/>
+          </a:solidFill>
+          <a:ln/>
+        </p:spPr>
+      </p:sp>
+      <p:sp>
+        <p:nvSpPr>
+          <p:cNvPr id="113" name="Shape 110"/>
           <p:cNvSpPr/>
           <p:nvPr/>
         </p:nvSpPr>
@@ -5774,14 +5556,14 @@
             <a:avLst/>
           </a:prstGeom>
           <a:solidFill>
-            <a:srgbClr val="F5B301"/>
-          </a:solidFill>
-          <a:ln/>
-        </p:spPr>
-      </p:sp>
-      <p:sp>
-        <p:nvSpPr>
-          <p:cNvPr id="113" name="Text 111"/>
+            <a:srgbClr val="E45D4A"/>
+          </a:solidFill>
+          <a:ln/>
+        </p:spPr>
+      </p:sp>
+      <p:sp>
+        <p:nvSpPr>
+          <p:cNvPr id="114" name="Text 111"/>
           <p:cNvSpPr/>
           <p:nvPr/>
         </p:nvSpPr>
@@ -5820,7 +5602,7 @@
       </p:sp>
       <p:sp>
         <p:nvSpPr>
-          <p:cNvPr id="114" name="Text 112"/>
+          <p:cNvPr id="115" name="Text 112"/>
           <p:cNvSpPr/>
           <p:nvPr/>
         </p:nvSpPr>
@@ -5957,7 +5739,7 @@
       </p:sp>
       <p:sp>
         <p:nvSpPr>
-          <p:cNvPr id="115" name="Text 113"/>
+          <p:cNvPr id="116" name="Text 113"/>
           <p:cNvSpPr/>
           <p:nvPr/>
         </p:nvSpPr>
@@ -5996,7 +5778,7 @@
       </p:sp>
       <p:sp>
         <p:nvSpPr>
-          <p:cNvPr id="116" name="Shape 114"/>
+          <p:cNvPr id="117" name="Shape 114"/>
           <p:cNvSpPr/>
           <p:nvPr/>
         </p:nvSpPr>
@@ -6011,14 +5793,14 @@
             </a:avLst>
           </a:prstGeom>
           <a:solidFill>
-            <a:srgbClr val="1F4E9B"/>
-          </a:solidFill>
-          <a:ln/>
-        </p:spPr>
-      </p:sp>
-      <p:sp>
-        <p:nvSpPr>
-          <p:cNvPr id="117" name="Text 115"/>
+            <a:srgbClr val="22346B"/>
+          </a:solidFill>
+          <a:ln/>
+        </p:spPr>
+      </p:sp>
+      <p:sp>
+        <p:nvSpPr>
+          <p:cNvPr id="118" name="Text 115"/>
           <p:cNvSpPr/>
           <p:nvPr/>
         </p:nvSpPr>
@@ -6043,7 +5825,7 @@
             <a:r>
               <a:rPr lang="en-US" sz="800" dirty="0">
                 <a:solidFill>
-                  <a:srgbClr val="6B7480"/>
+                  <a:srgbClr val="5B6672"/>
                 </a:solidFill>
                 <a:latin typeface="Calibri" pitchFamily="34" charset="0"/>
                 <a:ea typeface="Calibri" pitchFamily="34" charset="-122"/>
@@ -6057,7 +5839,7 @@
       </p:sp>
       <p:sp>
         <p:nvSpPr>
-          <p:cNvPr id="118" name="Shape 116"/>
+          <p:cNvPr id="119" name="Shape 116"/>
           <p:cNvSpPr/>
           <p:nvPr/>
         </p:nvSpPr>
@@ -6070,14 +5852,14 @@
             <a:avLst/>
           </a:prstGeom>
           <a:solidFill>
-            <a:srgbClr val="F5B301"/>
-          </a:solidFill>
-          <a:ln/>
-        </p:spPr>
-      </p:sp>
-      <p:sp>
-        <p:nvSpPr>
-          <p:cNvPr id="119" name="Text 117"/>
+            <a:srgbClr val="E45D4A"/>
+          </a:solidFill>
+          <a:ln/>
+        </p:spPr>
+      </p:sp>
+      <p:sp>
+        <p:nvSpPr>
+          <p:cNvPr id="120" name="Text 117"/>
           <p:cNvSpPr/>
           <p:nvPr/>
         </p:nvSpPr>
@@ -6102,7 +5884,7 @@
             <a:r>
               <a:rPr lang="en-US" sz="800" dirty="0">
                 <a:solidFill>
-                  <a:srgbClr val="6B7480"/>
+                  <a:srgbClr val="5B6672"/>
                 </a:solidFill>
                 <a:latin typeface="Calibri" pitchFamily="34" charset="0"/>
                 <a:ea typeface="Calibri" pitchFamily="34" charset="-122"/>
@@ -6116,7 +5898,7 @@
       </p:sp>
       <p:sp>
         <p:nvSpPr>
-          <p:cNvPr id="120" name="Shape 118"/>
+          <p:cNvPr id="121" name="Shape 118"/>
           <p:cNvSpPr/>
           <p:nvPr/>
         </p:nvSpPr>
@@ -6131,14 +5913,14 @@
             </a:avLst>
           </a:prstGeom>
           <a:solidFill>
-            <a:srgbClr val="F4DAD8"/>
-          </a:solidFill>
-          <a:ln/>
-        </p:spPr>
-      </p:sp>
-      <p:sp>
-        <p:nvSpPr>
-          <p:cNvPr id="121" name="Text 119"/>
+            <a:srgbClr val="F3DBD7"/>
+          </a:solidFill>
+          <a:ln/>
+        </p:spPr>
+      </p:sp>
+      <p:sp>
+        <p:nvSpPr>
+          <p:cNvPr id="122" name="Text 119"/>
           <p:cNvSpPr/>
           <p:nvPr/>
         </p:nvSpPr>
@@ -6163,7 +5945,7 @@
             <a:r>
               <a:rPr lang="en-US" sz="800" dirty="0">
                 <a:solidFill>
-                  <a:srgbClr val="6B7480"/>
+                  <a:srgbClr val="5B6672"/>
                 </a:solidFill>
                 <a:latin typeface="Calibri" pitchFamily="34" charset="0"/>
                 <a:ea typeface="Calibri" pitchFamily="34" charset="-122"/>
@@ -6177,7 +5959,7 @@
       </p:sp>
       <p:sp>
         <p:nvSpPr>
-          <p:cNvPr id="122" name="Shape 120"/>
+          <p:cNvPr id="123" name="Shape 120"/>
           <p:cNvSpPr/>
           <p:nvPr/>
         </p:nvSpPr>
@@ -6192,14 +5974,14 @@
             </a:avLst>
           </a:prstGeom>
           <a:solidFill>
-            <a:srgbClr val="EAF5EC"/>
-          </a:solidFill>
-          <a:ln/>
-        </p:spPr>
-      </p:sp>
-      <p:sp>
-        <p:nvSpPr>
-          <p:cNvPr id="123" name="Text 121"/>
+            <a:srgbClr val="DCEEEA"/>
+          </a:solidFill>
+          <a:ln/>
+        </p:spPr>
+      </p:sp>
+      <p:sp>
+        <p:nvSpPr>
+          <p:cNvPr id="124" name="Text 121"/>
           <p:cNvSpPr/>
           <p:nvPr/>
         </p:nvSpPr>
@@ -6224,7 +6006,7 @@
             <a:r>
               <a:rPr lang="en-US" sz="800" dirty="0">
                 <a:solidFill>
-                  <a:srgbClr val="6B7480"/>
+                  <a:srgbClr val="5B6672"/>
                 </a:solidFill>
                 <a:latin typeface="Calibri" pitchFamily="34" charset="0"/>
                 <a:ea typeface="Calibri" pitchFamily="34" charset="-122"/>
@@ -6283,7 +6065,7 @@
             <a:avLst/>
           </a:prstGeom>
           <a:solidFill>
-            <a:srgbClr val="16305C"/>
+            <a:srgbClr val="22346B"/>
           </a:solidFill>
           <a:ln/>
         </p:spPr>
@@ -6303,7 +6085,7 @@
             <a:avLst/>
           </a:prstGeom>
           <a:solidFill>
-            <a:srgbClr val="F5B301"/>
+            <a:srgbClr val="E45D4A"/>
           </a:solidFill>
           <a:ln/>
         </p:spPr>
@@ -6317,7 +6099,7 @@
         <p:spPr>
           <a:xfrm>
             <a:off x="365760" y="0"/>
-            <a:ext cx="8686800" cy="786384"/>
+            <a:ext cx="7863840" cy="786384"/>
           </a:xfrm>
           <a:prstGeom prst="rect">
             <a:avLst/>
@@ -6356,7 +6138,7 @@
         <p:spPr>
           <a:xfrm>
             <a:off x="8229600" y="0"/>
-            <a:ext cx="3657600" cy="786384"/>
+            <a:ext cx="2148840" cy="786384"/>
           </a:xfrm>
           <a:prstGeom prst="rect">
             <a:avLst/>
@@ -6374,7 +6156,7 @@
             <a:r>
               <a:rPr lang="en-US" sz="1100" b="1" dirty="0">
                 <a:solidFill>
-                  <a:srgbClr val="F5B301"/>
+                  <a:srgbClr val="E45D4A"/>
                 </a:solidFill>
                 <a:latin typeface="Calibri" pitchFamily="34" charset="0"/>
                 <a:ea typeface="Calibri" pitchFamily="34" charset="-122"/>
@@ -6386,9 +6168,33 @@
           </a:p>
         </p:txBody>
       </p:sp>
-      <p:sp>
-        <p:nvSpPr>
-          <p:cNvPr id="6" name="Shape 4"/>
+      <p:pic>
+        <p:nvPicPr>
+          <p:cNvPr id="6" name="Image 0" descr="/home/user/PPT---RH/rh/aura_logo_white.png">    </p:cNvPr>
+          <p:cNvPicPr>
+            <a:picLocks noChangeAspect="1"/>
+          </p:cNvPicPr>
+          <p:nvPr/>
+        </p:nvPicPr>
+        <p:blipFill>
+          <a:blip r:embed="rId1"/>
+          <a:stretch>
+            <a:fillRect/>
+          </a:stretch>
+        </p:blipFill>
+        <p:spPr>
+          <a:xfrm>
+            <a:off x="10927080" y="155448"/>
+            <a:ext cx="813816" cy="475488"/>
+          </a:xfrm>
+          <a:prstGeom prst="rect">
+            <a:avLst/>
+          </a:prstGeom>
+        </p:spPr>
+      </p:pic>
+      <p:sp>
+        <p:nvSpPr>
+          <p:cNvPr id="7" name="Shape 4"/>
           <p:cNvSpPr/>
           <p:nvPr/>
         </p:nvSpPr>
@@ -6408,7 +6214,7 @@
       </p:sp>
       <p:sp>
         <p:nvSpPr>
-          <p:cNvPr id="7" name="Shape 5"/>
+          <p:cNvPr id="8" name="Shape 5"/>
           <p:cNvSpPr/>
           <p:nvPr/>
         </p:nvSpPr>
@@ -6423,7 +6229,7 @@
           <a:noFill/>
           <a:ln w="17780">
             <a:solidFill>
-              <a:srgbClr val="1F4E9B"/>
+              <a:srgbClr val="22346B"/>
             </a:solidFill>
             <a:prstDash val="solid"/>
             <a:headEnd type="none"/>
@@ -6433,7 +6239,7 @@
       </p:sp>
       <p:sp>
         <p:nvSpPr>
-          <p:cNvPr id="8" name="Shape 6"/>
+          <p:cNvPr id="9" name="Shape 6"/>
           <p:cNvSpPr/>
           <p:nvPr/>
         </p:nvSpPr>
@@ -6467,7 +6273,7 @@
       </p:sp>
       <p:sp>
         <p:nvSpPr>
-          <p:cNvPr id="9" name="Shape 7"/>
+          <p:cNvPr id="10" name="Shape 7"/>
           <p:cNvSpPr/>
           <p:nvPr/>
         </p:nvSpPr>
@@ -6480,14 +6286,14 @@
             <a:avLst/>
           </a:prstGeom>
           <a:solidFill>
-            <a:srgbClr val="1F4E9B"/>
-          </a:solidFill>
-          <a:ln/>
-        </p:spPr>
-      </p:sp>
-      <p:sp>
-        <p:nvSpPr>
-          <p:cNvPr id="10" name="Text 8"/>
+            <a:srgbClr val="22346B"/>
+          </a:solidFill>
+          <a:ln/>
+        </p:spPr>
+      </p:sp>
+      <p:sp>
+        <p:nvSpPr>
+          <p:cNvPr id="11" name="Text 8"/>
           <p:cNvSpPr/>
           <p:nvPr/>
         </p:nvSpPr>
@@ -6518,7 +6324,7 @@
             <a:r>
               <a:rPr lang="en-US" sz="1200" b="1" dirty="0">
                 <a:solidFill>
-                  <a:srgbClr val="16305C"/>
+                  <a:srgbClr val="22346B"/>
                 </a:solidFill>
                 <a:latin typeface="Calibri" pitchFamily="34" charset="0"/>
                 <a:ea typeface="Calibri" pitchFamily="34" charset="-122"/>
@@ -6538,7 +6344,7 @@
             <a:r>
               <a:rPr lang="en-US" sz="830" dirty="0">
                 <a:solidFill>
-                  <a:srgbClr val="6B7480"/>
+                  <a:srgbClr val="5B6672"/>
                 </a:solidFill>
                 <a:latin typeface="Calibri" pitchFamily="34" charset="0"/>
                 <a:ea typeface="Calibri" pitchFamily="34" charset="-122"/>
@@ -6552,7 +6358,7 @@
       </p:sp>
       <p:sp>
         <p:nvSpPr>
-          <p:cNvPr id="11" name="Shape 9"/>
+          <p:cNvPr id="12" name="Shape 9"/>
           <p:cNvSpPr/>
           <p:nvPr/>
         </p:nvSpPr>
@@ -6565,7 +6371,7 @@
             <a:avLst/>
           </a:prstGeom>
           <a:solidFill>
-            <a:srgbClr val="1F4E9B"/>
+            <a:srgbClr val="22346B"/>
           </a:solidFill>
           <a:ln/>
           <a:effectLst>
@@ -6579,7 +6385,7 @@
       </p:sp>
       <p:sp>
         <p:nvSpPr>
-          <p:cNvPr id="12" name="Text 10"/>
+          <p:cNvPr id="13" name="Text 10"/>
           <p:cNvSpPr/>
           <p:nvPr/>
         </p:nvSpPr>
@@ -6618,7 +6424,7 @@
       </p:sp>
       <p:sp>
         <p:nvSpPr>
-          <p:cNvPr id="13" name="Shape 11"/>
+          <p:cNvPr id="14" name="Shape 11"/>
           <p:cNvSpPr/>
           <p:nvPr/>
         </p:nvSpPr>
@@ -6633,7 +6439,7 @@
           <a:noFill/>
           <a:ln w="17780">
             <a:solidFill>
-              <a:srgbClr val="D99400"/>
+              <a:srgbClr val="C0402F"/>
             </a:solidFill>
             <a:prstDash val="solid"/>
             <a:headEnd type="none"/>
@@ -6643,7 +6449,7 @@
       </p:sp>
       <p:sp>
         <p:nvSpPr>
-          <p:cNvPr id="14" name="Shape 12"/>
+          <p:cNvPr id="15" name="Shape 12"/>
           <p:cNvSpPr/>
           <p:nvPr/>
         </p:nvSpPr>
@@ -6677,7 +6483,7 @@
       </p:sp>
       <p:sp>
         <p:nvSpPr>
-          <p:cNvPr id="15" name="Shape 13"/>
+          <p:cNvPr id="16" name="Shape 13"/>
           <p:cNvSpPr/>
           <p:nvPr/>
         </p:nvSpPr>
@@ -6690,14 +6496,14 @@
             <a:avLst/>
           </a:prstGeom>
           <a:solidFill>
-            <a:srgbClr val="D99400"/>
-          </a:solidFill>
-          <a:ln/>
-        </p:spPr>
-      </p:sp>
-      <p:sp>
-        <p:nvSpPr>
-          <p:cNvPr id="16" name="Text 14"/>
+            <a:srgbClr val="C0402F"/>
+          </a:solidFill>
+          <a:ln/>
+        </p:spPr>
+      </p:sp>
+      <p:sp>
+        <p:nvSpPr>
+          <p:cNvPr id="17" name="Text 14"/>
           <p:cNvSpPr/>
           <p:nvPr/>
         </p:nvSpPr>
@@ -6728,7 +6534,7 @@
             <a:r>
               <a:rPr lang="en-US" sz="1200" b="1" dirty="0">
                 <a:solidFill>
-                  <a:srgbClr val="16305C"/>
+                  <a:srgbClr val="22346B"/>
                 </a:solidFill>
                 <a:latin typeface="Calibri" pitchFamily="34" charset="0"/>
                 <a:ea typeface="Calibri" pitchFamily="34" charset="-122"/>
@@ -6748,7 +6554,7 @@
             <a:r>
               <a:rPr lang="en-US" sz="830" dirty="0">
                 <a:solidFill>
-                  <a:srgbClr val="6B7480"/>
+                  <a:srgbClr val="5B6672"/>
                 </a:solidFill>
                 <a:latin typeface="Calibri" pitchFamily="34" charset="0"/>
                 <a:ea typeface="Calibri" pitchFamily="34" charset="-122"/>
@@ -6762,7 +6568,7 @@
       </p:sp>
       <p:sp>
         <p:nvSpPr>
-          <p:cNvPr id="17" name="Shape 15"/>
+          <p:cNvPr id="18" name="Shape 15"/>
           <p:cNvSpPr/>
           <p:nvPr/>
         </p:nvSpPr>
@@ -6775,7 +6581,7 @@
             <a:avLst/>
           </a:prstGeom>
           <a:solidFill>
-            <a:srgbClr val="D99400"/>
+            <a:srgbClr val="C0402F"/>
           </a:solidFill>
           <a:ln/>
           <a:effectLst>
@@ -6789,7 +6595,7 @@
       </p:sp>
       <p:sp>
         <p:nvSpPr>
-          <p:cNvPr id="18" name="Text 16"/>
+          <p:cNvPr id="19" name="Text 16"/>
           <p:cNvSpPr/>
           <p:nvPr/>
         </p:nvSpPr>
@@ -6828,7 +6634,7 @@
       </p:sp>
       <p:sp>
         <p:nvSpPr>
-          <p:cNvPr id="19" name="Shape 17"/>
+          <p:cNvPr id="20" name="Shape 17"/>
           <p:cNvSpPr/>
           <p:nvPr/>
         </p:nvSpPr>
@@ -6843,7 +6649,7 @@
           <a:noFill/>
           <a:ln w="17780">
             <a:solidFill>
-              <a:srgbClr val="1F4E9B"/>
+              <a:srgbClr val="22346B"/>
             </a:solidFill>
             <a:prstDash val="solid"/>
             <a:headEnd type="none"/>
@@ -6853,7 +6659,7 @@
       </p:sp>
       <p:sp>
         <p:nvSpPr>
-          <p:cNvPr id="20" name="Shape 18"/>
+          <p:cNvPr id="21" name="Shape 18"/>
           <p:cNvSpPr/>
           <p:nvPr/>
         </p:nvSpPr>
@@ -6887,7 +6693,7 @@
       </p:sp>
       <p:sp>
         <p:nvSpPr>
-          <p:cNvPr id="21" name="Shape 19"/>
+          <p:cNvPr id="22" name="Shape 19"/>
           <p:cNvSpPr/>
           <p:nvPr/>
         </p:nvSpPr>
@@ -6900,14 +6706,14 @@
             <a:avLst/>
           </a:prstGeom>
           <a:solidFill>
-            <a:srgbClr val="1F4E9B"/>
-          </a:solidFill>
-          <a:ln/>
-        </p:spPr>
-      </p:sp>
-      <p:sp>
-        <p:nvSpPr>
-          <p:cNvPr id="22" name="Text 20"/>
+            <a:srgbClr val="22346B"/>
+          </a:solidFill>
+          <a:ln/>
+        </p:spPr>
+      </p:sp>
+      <p:sp>
+        <p:nvSpPr>
+          <p:cNvPr id="23" name="Text 20"/>
           <p:cNvSpPr/>
           <p:nvPr/>
         </p:nvSpPr>
@@ -6938,7 +6744,7 @@
             <a:r>
               <a:rPr lang="en-US" sz="1200" b="1" dirty="0">
                 <a:solidFill>
-                  <a:srgbClr val="16305C"/>
+                  <a:srgbClr val="22346B"/>
                 </a:solidFill>
                 <a:latin typeface="Calibri" pitchFamily="34" charset="0"/>
                 <a:ea typeface="Calibri" pitchFamily="34" charset="-122"/>
@@ -6958,7 +6764,7 @@
             <a:r>
               <a:rPr lang="en-US" sz="830" dirty="0">
                 <a:solidFill>
-                  <a:srgbClr val="6B7480"/>
+                  <a:srgbClr val="5B6672"/>
                 </a:solidFill>
                 <a:latin typeface="Calibri" pitchFamily="34" charset="0"/>
                 <a:ea typeface="Calibri" pitchFamily="34" charset="-122"/>
@@ -6972,7 +6778,7 @@
       </p:sp>
       <p:sp>
         <p:nvSpPr>
-          <p:cNvPr id="23" name="Shape 21"/>
+          <p:cNvPr id="24" name="Shape 21"/>
           <p:cNvSpPr/>
           <p:nvPr/>
         </p:nvSpPr>
@@ -6985,7 +6791,7 @@
             <a:avLst/>
           </a:prstGeom>
           <a:solidFill>
-            <a:srgbClr val="1F4E9B"/>
+            <a:srgbClr val="22346B"/>
           </a:solidFill>
           <a:ln/>
           <a:effectLst>
@@ -6999,7 +6805,7 @@
       </p:sp>
       <p:sp>
         <p:nvSpPr>
-          <p:cNvPr id="24" name="Text 22"/>
+          <p:cNvPr id="25" name="Text 22"/>
           <p:cNvSpPr/>
           <p:nvPr/>
         </p:nvSpPr>
@@ -7038,7 +6844,7 @@
       </p:sp>
       <p:sp>
         <p:nvSpPr>
-          <p:cNvPr id="25" name="Shape 23"/>
+          <p:cNvPr id="26" name="Shape 23"/>
           <p:cNvSpPr/>
           <p:nvPr/>
         </p:nvSpPr>
@@ -7053,7 +6859,7 @@
           <a:noFill/>
           <a:ln w="17780">
             <a:solidFill>
-              <a:srgbClr val="D99400"/>
+              <a:srgbClr val="C0402F"/>
             </a:solidFill>
             <a:prstDash val="solid"/>
             <a:headEnd type="none"/>
@@ -7063,7 +6869,7 @@
       </p:sp>
       <p:sp>
         <p:nvSpPr>
-          <p:cNvPr id="26" name="Shape 24"/>
+          <p:cNvPr id="27" name="Shape 24"/>
           <p:cNvSpPr/>
           <p:nvPr/>
         </p:nvSpPr>
@@ -7097,7 +6903,7 @@
       </p:sp>
       <p:sp>
         <p:nvSpPr>
-          <p:cNvPr id="27" name="Shape 25"/>
+          <p:cNvPr id="28" name="Shape 25"/>
           <p:cNvSpPr/>
           <p:nvPr/>
         </p:nvSpPr>
@@ -7110,14 +6916,14 @@
             <a:avLst/>
           </a:prstGeom>
           <a:solidFill>
-            <a:srgbClr val="D99400"/>
-          </a:solidFill>
-          <a:ln/>
-        </p:spPr>
-      </p:sp>
-      <p:sp>
-        <p:nvSpPr>
-          <p:cNvPr id="28" name="Text 26"/>
+            <a:srgbClr val="C0402F"/>
+          </a:solidFill>
+          <a:ln/>
+        </p:spPr>
+      </p:sp>
+      <p:sp>
+        <p:nvSpPr>
+          <p:cNvPr id="29" name="Text 26"/>
           <p:cNvSpPr/>
           <p:nvPr/>
         </p:nvSpPr>
@@ -7148,7 +6954,7 @@
             <a:r>
               <a:rPr lang="en-US" sz="1200" b="1" dirty="0">
                 <a:solidFill>
-                  <a:srgbClr val="16305C"/>
+                  <a:srgbClr val="22346B"/>
                 </a:solidFill>
                 <a:latin typeface="Calibri" pitchFamily="34" charset="0"/>
                 <a:ea typeface="Calibri" pitchFamily="34" charset="-122"/>
@@ -7168,7 +6974,7 @@
             <a:r>
               <a:rPr lang="en-US" sz="830" dirty="0">
                 <a:solidFill>
-                  <a:srgbClr val="6B7480"/>
+                  <a:srgbClr val="5B6672"/>
                 </a:solidFill>
                 <a:latin typeface="Calibri" pitchFamily="34" charset="0"/>
                 <a:ea typeface="Calibri" pitchFamily="34" charset="-122"/>
@@ -7182,7 +6988,7 @@
       </p:sp>
       <p:sp>
         <p:nvSpPr>
-          <p:cNvPr id="29" name="Shape 27"/>
+          <p:cNvPr id="30" name="Shape 27"/>
           <p:cNvSpPr/>
           <p:nvPr/>
         </p:nvSpPr>
@@ -7195,7 +7001,7 @@
             <a:avLst/>
           </a:prstGeom>
           <a:solidFill>
-            <a:srgbClr val="D99400"/>
+            <a:srgbClr val="C0402F"/>
           </a:solidFill>
           <a:ln/>
           <a:effectLst>
@@ -7209,7 +7015,7 @@
       </p:sp>
       <p:sp>
         <p:nvSpPr>
-          <p:cNvPr id="30" name="Text 28"/>
+          <p:cNvPr id="31" name="Text 28"/>
           <p:cNvSpPr/>
           <p:nvPr/>
         </p:nvSpPr>
@@ -7248,7 +7054,7 @@
       </p:sp>
       <p:sp>
         <p:nvSpPr>
-          <p:cNvPr id="31" name="Shape 29"/>
+          <p:cNvPr id="32" name="Shape 29"/>
           <p:cNvSpPr/>
           <p:nvPr/>
         </p:nvSpPr>
@@ -7263,7 +7069,7 @@
           <a:noFill/>
           <a:ln w="17780">
             <a:solidFill>
-              <a:srgbClr val="1F4E9B"/>
+              <a:srgbClr val="22346B"/>
             </a:solidFill>
             <a:prstDash val="solid"/>
             <a:headEnd type="none"/>
@@ -7273,7 +7079,7 @@
       </p:sp>
       <p:sp>
         <p:nvSpPr>
-          <p:cNvPr id="32" name="Shape 30"/>
+          <p:cNvPr id="33" name="Shape 30"/>
           <p:cNvSpPr/>
           <p:nvPr/>
         </p:nvSpPr>
@@ -7307,7 +7113,7 @@
       </p:sp>
       <p:sp>
         <p:nvSpPr>
-          <p:cNvPr id="33" name="Shape 31"/>
+          <p:cNvPr id="34" name="Shape 31"/>
           <p:cNvSpPr/>
           <p:nvPr/>
         </p:nvSpPr>
@@ -7320,14 +7126,14 @@
             <a:avLst/>
           </a:prstGeom>
           <a:solidFill>
-            <a:srgbClr val="1F4E9B"/>
-          </a:solidFill>
-          <a:ln/>
-        </p:spPr>
-      </p:sp>
-      <p:sp>
-        <p:nvSpPr>
-          <p:cNvPr id="34" name="Text 32"/>
+            <a:srgbClr val="22346B"/>
+          </a:solidFill>
+          <a:ln/>
+        </p:spPr>
+      </p:sp>
+      <p:sp>
+        <p:nvSpPr>
+          <p:cNvPr id="35" name="Text 32"/>
           <p:cNvSpPr/>
           <p:nvPr/>
         </p:nvSpPr>
@@ -7358,7 +7164,7 @@
             <a:r>
               <a:rPr lang="en-US" sz="1200" b="1" dirty="0">
                 <a:solidFill>
-                  <a:srgbClr val="16305C"/>
+                  <a:srgbClr val="22346B"/>
                 </a:solidFill>
                 <a:latin typeface="Calibri" pitchFamily="34" charset="0"/>
                 <a:ea typeface="Calibri" pitchFamily="34" charset="-122"/>
@@ -7378,7 +7184,7 @@
             <a:r>
               <a:rPr lang="en-US" sz="830" dirty="0">
                 <a:solidFill>
-                  <a:srgbClr val="6B7480"/>
+                  <a:srgbClr val="5B6672"/>
                 </a:solidFill>
                 <a:latin typeface="Calibri" pitchFamily="34" charset="0"/>
                 <a:ea typeface="Calibri" pitchFamily="34" charset="-122"/>
@@ -7392,7 +7198,7 @@
       </p:sp>
       <p:sp>
         <p:nvSpPr>
-          <p:cNvPr id="35" name="Shape 33"/>
+          <p:cNvPr id="36" name="Shape 33"/>
           <p:cNvSpPr/>
           <p:nvPr/>
         </p:nvSpPr>
@@ -7405,7 +7211,7 @@
             <a:avLst/>
           </a:prstGeom>
           <a:solidFill>
-            <a:srgbClr val="1F4E9B"/>
+            <a:srgbClr val="22346B"/>
           </a:solidFill>
           <a:ln/>
           <a:effectLst>
@@ -7419,7 +7225,7 @@
       </p:sp>
       <p:sp>
         <p:nvSpPr>
-          <p:cNvPr id="36" name="Text 34"/>
+          <p:cNvPr id="37" name="Text 34"/>
           <p:cNvSpPr/>
           <p:nvPr/>
         </p:nvSpPr>
@@ -7458,7 +7264,7 @@
       </p:sp>
       <p:sp>
         <p:nvSpPr>
-          <p:cNvPr id="37" name="Shape 35"/>
+          <p:cNvPr id="38" name="Shape 35"/>
           <p:cNvSpPr/>
           <p:nvPr/>
         </p:nvSpPr>
@@ -7473,7 +7279,7 @@
           <a:noFill/>
           <a:ln w="17780">
             <a:solidFill>
-              <a:srgbClr val="D99400"/>
+              <a:srgbClr val="C0402F"/>
             </a:solidFill>
             <a:prstDash val="solid"/>
             <a:headEnd type="none"/>
@@ -7483,7 +7289,7 @@
       </p:sp>
       <p:sp>
         <p:nvSpPr>
-          <p:cNvPr id="38" name="Shape 36"/>
+          <p:cNvPr id="39" name="Shape 36"/>
           <p:cNvSpPr/>
           <p:nvPr/>
         </p:nvSpPr>
@@ -7517,7 +7323,7 @@
       </p:sp>
       <p:sp>
         <p:nvSpPr>
-          <p:cNvPr id="39" name="Shape 37"/>
+          <p:cNvPr id="40" name="Shape 37"/>
           <p:cNvSpPr/>
           <p:nvPr/>
         </p:nvSpPr>
@@ -7530,14 +7336,14 @@
             <a:avLst/>
           </a:prstGeom>
           <a:solidFill>
-            <a:srgbClr val="D99400"/>
-          </a:solidFill>
-          <a:ln/>
-        </p:spPr>
-      </p:sp>
-      <p:sp>
-        <p:nvSpPr>
-          <p:cNvPr id="40" name="Text 38"/>
+            <a:srgbClr val="C0402F"/>
+          </a:solidFill>
+          <a:ln/>
+        </p:spPr>
+      </p:sp>
+      <p:sp>
+        <p:nvSpPr>
+          <p:cNvPr id="41" name="Text 38"/>
           <p:cNvSpPr/>
           <p:nvPr/>
         </p:nvSpPr>
@@ -7568,7 +7374,7 @@
             <a:r>
               <a:rPr lang="en-US" sz="1200" b="1" dirty="0">
                 <a:solidFill>
-                  <a:srgbClr val="16305C"/>
+                  <a:srgbClr val="22346B"/>
                 </a:solidFill>
                 <a:latin typeface="Calibri" pitchFamily="34" charset="0"/>
                 <a:ea typeface="Calibri" pitchFamily="34" charset="-122"/>
@@ -7588,7 +7394,7 @@
             <a:r>
               <a:rPr lang="en-US" sz="830" dirty="0">
                 <a:solidFill>
-                  <a:srgbClr val="6B7480"/>
+                  <a:srgbClr val="5B6672"/>
                 </a:solidFill>
                 <a:latin typeface="Calibri" pitchFamily="34" charset="0"/>
                 <a:ea typeface="Calibri" pitchFamily="34" charset="-122"/>
@@ -7602,7 +7408,7 @@
       </p:sp>
       <p:sp>
         <p:nvSpPr>
-          <p:cNvPr id="41" name="Shape 39"/>
+          <p:cNvPr id="42" name="Shape 39"/>
           <p:cNvSpPr/>
           <p:nvPr/>
         </p:nvSpPr>
@@ -7615,7 +7421,7 @@
             <a:avLst/>
           </a:prstGeom>
           <a:solidFill>
-            <a:srgbClr val="D99400"/>
+            <a:srgbClr val="C0402F"/>
           </a:solidFill>
           <a:ln/>
           <a:effectLst>
@@ -7629,7 +7435,7 @@
       </p:sp>
       <p:sp>
         <p:nvSpPr>
-          <p:cNvPr id="42" name="Text 40"/>
+          <p:cNvPr id="43" name="Text 40"/>
           <p:cNvSpPr/>
           <p:nvPr/>
         </p:nvSpPr>
@@ -7668,7 +7474,7 @@
       </p:sp>
       <p:sp>
         <p:nvSpPr>
-          <p:cNvPr id="43" name="Shape 41"/>
+          <p:cNvPr id="44" name="Shape 41"/>
           <p:cNvSpPr/>
           <p:nvPr/>
         </p:nvSpPr>
@@ -7683,7 +7489,7 @@
           <a:noFill/>
           <a:ln w="17780">
             <a:solidFill>
-              <a:srgbClr val="1F4E9B"/>
+              <a:srgbClr val="22346B"/>
             </a:solidFill>
             <a:prstDash val="solid"/>
             <a:headEnd type="none"/>
@@ -7693,7 +7499,7 @@
       </p:sp>
       <p:sp>
         <p:nvSpPr>
-          <p:cNvPr id="44" name="Shape 42"/>
+          <p:cNvPr id="45" name="Shape 42"/>
           <p:cNvSpPr/>
           <p:nvPr/>
         </p:nvSpPr>
@@ -7727,7 +7533,7 @@
       </p:sp>
       <p:sp>
         <p:nvSpPr>
-          <p:cNvPr id="45" name="Shape 43"/>
+          <p:cNvPr id="46" name="Shape 43"/>
           <p:cNvSpPr/>
           <p:nvPr/>
         </p:nvSpPr>
@@ -7740,14 +7546,14 @@
             <a:avLst/>
           </a:prstGeom>
           <a:solidFill>
-            <a:srgbClr val="1F4E9B"/>
-          </a:solidFill>
-          <a:ln/>
-        </p:spPr>
-      </p:sp>
-      <p:sp>
-        <p:nvSpPr>
-          <p:cNvPr id="46" name="Text 44"/>
+            <a:srgbClr val="22346B"/>
+          </a:solidFill>
+          <a:ln/>
+        </p:spPr>
+      </p:sp>
+      <p:sp>
+        <p:nvSpPr>
+          <p:cNvPr id="47" name="Text 44"/>
           <p:cNvSpPr/>
           <p:nvPr/>
         </p:nvSpPr>
@@ -7778,7 +7584,7 @@
             <a:r>
               <a:rPr lang="en-US" sz="1200" b="1" dirty="0">
                 <a:solidFill>
-                  <a:srgbClr val="16305C"/>
+                  <a:srgbClr val="22346B"/>
                 </a:solidFill>
                 <a:latin typeface="Calibri" pitchFamily="34" charset="0"/>
                 <a:ea typeface="Calibri" pitchFamily="34" charset="-122"/>
@@ -7798,7 +7604,7 @@
             <a:r>
               <a:rPr lang="en-US" sz="830" dirty="0">
                 <a:solidFill>
-                  <a:srgbClr val="6B7480"/>
+                  <a:srgbClr val="5B6672"/>
                 </a:solidFill>
                 <a:latin typeface="Calibri" pitchFamily="34" charset="0"/>
                 <a:ea typeface="Calibri" pitchFamily="34" charset="-122"/>
@@ -7812,7 +7618,7 @@
       </p:sp>
       <p:sp>
         <p:nvSpPr>
-          <p:cNvPr id="47" name="Shape 45"/>
+          <p:cNvPr id="48" name="Shape 45"/>
           <p:cNvSpPr/>
           <p:nvPr/>
         </p:nvSpPr>
@@ -7825,7 +7631,7 @@
             <a:avLst/>
           </a:prstGeom>
           <a:solidFill>
-            <a:srgbClr val="1F4E9B"/>
+            <a:srgbClr val="22346B"/>
           </a:solidFill>
           <a:ln/>
           <a:effectLst>
@@ -7839,7 +7645,7 @@
       </p:sp>
       <p:sp>
         <p:nvSpPr>
-          <p:cNvPr id="48" name="Text 46"/>
+          <p:cNvPr id="49" name="Text 46"/>
           <p:cNvSpPr/>
           <p:nvPr/>
         </p:nvSpPr>
@@ -7878,7 +7684,7 @@
       </p:sp>
       <p:sp>
         <p:nvSpPr>
-          <p:cNvPr id="49" name="Shape 47"/>
+          <p:cNvPr id="50" name="Shape 47"/>
           <p:cNvSpPr/>
           <p:nvPr/>
         </p:nvSpPr>
@@ -7893,7 +7699,7 @@
           <a:noFill/>
           <a:ln w="17780">
             <a:solidFill>
-              <a:srgbClr val="D99400"/>
+              <a:srgbClr val="C0402F"/>
             </a:solidFill>
             <a:prstDash val="solid"/>
             <a:headEnd type="none"/>
@@ -7903,7 +7709,7 @@
       </p:sp>
       <p:sp>
         <p:nvSpPr>
-          <p:cNvPr id="50" name="Shape 48"/>
+          <p:cNvPr id="51" name="Shape 48"/>
           <p:cNvSpPr/>
           <p:nvPr/>
         </p:nvSpPr>
@@ -7937,7 +7743,7 @@
       </p:sp>
       <p:sp>
         <p:nvSpPr>
-          <p:cNvPr id="51" name="Shape 49"/>
+          <p:cNvPr id="52" name="Shape 49"/>
           <p:cNvSpPr/>
           <p:nvPr/>
         </p:nvSpPr>
@@ -7950,14 +7756,14 @@
             <a:avLst/>
           </a:prstGeom>
           <a:solidFill>
-            <a:srgbClr val="D99400"/>
-          </a:solidFill>
-          <a:ln/>
-        </p:spPr>
-      </p:sp>
-      <p:sp>
-        <p:nvSpPr>
-          <p:cNvPr id="52" name="Text 50"/>
+            <a:srgbClr val="C0402F"/>
+          </a:solidFill>
+          <a:ln/>
+        </p:spPr>
+      </p:sp>
+      <p:sp>
+        <p:nvSpPr>
+          <p:cNvPr id="53" name="Text 50"/>
           <p:cNvSpPr/>
           <p:nvPr/>
         </p:nvSpPr>
@@ -7988,7 +7794,7 @@
             <a:r>
               <a:rPr lang="en-US" sz="1200" b="1" dirty="0">
                 <a:solidFill>
-                  <a:srgbClr val="16305C"/>
+                  <a:srgbClr val="22346B"/>
                 </a:solidFill>
                 <a:latin typeface="Calibri" pitchFamily="34" charset="0"/>
                 <a:ea typeface="Calibri" pitchFamily="34" charset="-122"/>
@@ -8008,7 +7814,7 @@
             <a:r>
               <a:rPr lang="en-US" sz="830" dirty="0">
                 <a:solidFill>
-                  <a:srgbClr val="6B7480"/>
+                  <a:srgbClr val="5B6672"/>
                 </a:solidFill>
                 <a:latin typeface="Calibri" pitchFamily="34" charset="0"/>
                 <a:ea typeface="Calibri" pitchFamily="34" charset="-122"/>
@@ -8022,7 +7828,7 @@
       </p:sp>
       <p:sp>
         <p:nvSpPr>
-          <p:cNvPr id="53" name="Shape 51"/>
+          <p:cNvPr id="54" name="Shape 51"/>
           <p:cNvSpPr/>
           <p:nvPr/>
         </p:nvSpPr>
@@ -8035,7 +7841,7 @@
             <a:avLst/>
           </a:prstGeom>
           <a:solidFill>
-            <a:srgbClr val="D99400"/>
+            <a:srgbClr val="C0402F"/>
           </a:solidFill>
           <a:ln/>
           <a:effectLst>
@@ -8049,7 +7855,7 @@
       </p:sp>
       <p:sp>
         <p:nvSpPr>
-          <p:cNvPr id="54" name="Text 52"/>
+          <p:cNvPr id="55" name="Text 52"/>
           <p:cNvSpPr/>
           <p:nvPr/>
         </p:nvSpPr>
@@ -8088,7 +7894,7 @@
       </p:sp>
       <p:sp>
         <p:nvSpPr>
-          <p:cNvPr id="55" name="Text 53"/>
+          <p:cNvPr id="56" name="Text 53"/>
           <p:cNvSpPr/>
           <p:nvPr/>
         </p:nvSpPr>
@@ -8113,7 +7919,7 @@
             <a:r>
               <a:rPr lang="en-US" sz="1200" i="1" dirty="0">
                 <a:solidFill>
-                  <a:srgbClr val="6B7480"/>
+                  <a:srgbClr val="5B6672"/>
                 </a:solidFill>
                 <a:latin typeface="Calibri" pitchFamily="34" charset="0"/>
                 <a:ea typeface="Calibri" pitchFamily="34" charset="-122"/>
@@ -8127,7 +7933,7 @@
       </p:sp>
       <p:sp>
         <p:nvSpPr>
-          <p:cNvPr id="56" name="Shape 54"/>
+          <p:cNvPr id="57" name="Shape 54"/>
           <p:cNvSpPr/>
           <p:nvPr/>
         </p:nvSpPr>
@@ -8156,7 +7962,7 @@
       </p:sp>
       <p:sp>
         <p:nvSpPr>
-          <p:cNvPr id="57" name="Shape 55"/>
+          <p:cNvPr id="58" name="Shape 55"/>
           <p:cNvSpPr/>
           <p:nvPr/>
         </p:nvSpPr>
@@ -8169,14 +7975,14 @@
             <a:avLst/>
           </a:prstGeom>
           <a:solidFill>
-            <a:srgbClr val="1F4E9B"/>
-          </a:solidFill>
-          <a:ln/>
-        </p:spPr>
-      </p:sp>
-      <p:sp>
-        <p:nvSpPr>
-          <p:cNvPr id="58" name="Text 56"/>
+            <a:srgbClr val="22346B"/>
+          </a:solidFill>
+          <a:ln/>
+        </p:spPr>
+      </p:sp>
+      <p:sp>
+        <p:nvSpPr>
+          <p:cNvPr id="59" name="Text 56"/>
           <p:cNvSpPr/>
           <p:nvPr/>
         </p:nvSpPr>
@@ -8201,7 +8007,7 @@
             <a:r>
               <a:rPr lang="en-US" sz="2600" b="1" dirty="0">
                 <a:solidFill>
-                  <a:srgbClr val="1F4E9B"/>
+                  <a:srgbClr val="22346B"/>
                 </a:solidFill>
                 <a:latin typeface="Calibri" pitchFamily="34" charset="0"/>
                 <a:ea typeface="Calibri" pitchFamily="34" charset="-122"/>
@@ -8215,7 +8021,7 @@
       </p:sp>
       <p:sp>
         <p:nvSpPr>
-          <p:cNvPr id="59" name="Text 57"/>
+          <p:cNvPr id="60" name="Text 57"/>
           <p:cNvSpPr/>
           <p:nvPr/>
         </p:nvSpPr>
@@ -8254,7 +8060,7 @@
       </p:sp>
       <p:sp>
         <p:nvSpPr>
-          <p:cNvPr id="60" name="Shape 58"/>
+          <p:cNvPr id="61" name="Shape 58"/>
           <p:cNvSpPr/>
           <p:nvPr/>
         </p:nvSpPr>
@@ -8283,7 +8089,7 @@
       </p:sp>
       <p:sp>
         <p:nvSpPr>
-          <p:cNvPr id="61" name="Shape 59"/>
+          <p:cNvPr id="62" name="Shape 59"/>
           <p:cNvSpPr/>
           <p:nvPr/>
         </p:nvSpPr>
@@ -8296,14 +8102,14 @@
             <a:avLst/>
           </a:prstGeom>
           <a:solidFill>
-            <a:srgbClr val="D99400"/>
-          </a:solidFill>
-          <a:ln/>
-        </p:spPr>
-      </p:sp>
-      <p:sp>
-        <p:nvSpPr>
-          <p:cNvPr id="62" name="Text 60"/>
+            <a:srgbClr val="E45D4A"/>
+          </a:solidFill>
+          <a:ln/>
+        </p:spPr>
+      </p:sp>
+      <p:sp>
+        <p:nvSpPr>
+          <p:cNvPr id="63" name="Text 60"/>
           <p:cNvSpPr/>
           <p:nvPr/>
         </p:nvSpPr>
@@ -8328,7 +8134,7 @@
             <a:r>
               <a:rPr lang="en-US" sz="2600" b="1" dirty="0">
                 <a:solidFill>
-                  <a:srgbClr val="D99400"/>
+                  <a:srgbClr val="E45D4A"/>
                 </a:solidFill>
                 <a:latin typeface="Calibri" pitchFamily="34" charset="0"/>
                 <a:ea typeface="Calibri" pitchFamily="34" charset="-122"/>
@@ -8342,7 +8148,7 @@
       </p:sp>
       <p:sp>
         <p:nvSpPr>
-          <p:cNvPr id="63" name="Text 61"/>
+          <p:cNvPr id="64" name="Text 61"/>
           <p:cNvSpPr/>
           <p:nvPr/>
         </p:nvSpPr>
@@ -8381,7 +8187,7 @@
       </p:sp>
       <p:sp>
         <p:nvSpPr>
-          <p:cNvPr id="64" name="Shape 62"/>
+          <p:cNvPr id="65" name="Shape 62"/>
           <p:cNvSpPr/>
           <p:nvPr/>
         </p:nvSpPr>
@@ -8410,7 +8216,7 @@
       </p:sp>
       <p:sp>
         <p:nvSpPr>
-          <p:cNvPr id="65" name="Shape 63"/>
+          <p:cNvPr id="66" name="Shape 63"/>
           <p:cNvSpPr/>
           <p:nvPr/>
         </p:nvSpPr>
@@ -8423,14 +8229,14 @@
             <a:avLst/>
           </a:prstGeom>
           <a:solidFill>
-            <a:srgbClr val="1F4E9B"/>
-          </a:solidFill>
-          <a:ln/>
-        </p:spPr>
-      </p:sp>
-      <p:sp>
-        <p:nvSpPr>
-          <p:cNvPr id="66" name="Text 64"/>
+            <a:srgbClr val="1E8A80"/>
+          </a:solidFill>
+          <a:ln/>
+        </p:spPr>
+      </p:sp>
+      <p:sp>
+        <p:nvSpPr>
+          <p:cNvPr id="67" name="Text 64"/>
           <p:cNvSpPr/>
           <p:nvPr/>
         </p:nvSpPr>
@@ -8455,7 +8261,7 @@
             <a:r>
               <a:rPr lang="en-US" sz="2600" b="1" dirty="0">
                 <a:solidFill>
-                  <a:srgbClr val="1F4E9B"/>
+                  <a:srgbClr val="1E8A80"/>
                 </a:solidFill>
                 <a:latin typeface="Calibri" pitchFamily="34" charset="0"/>
                 <a:ea typeface="Calibri" pitchFamily="34" charset="-122"/>
@@ -8469,7 +8275,7 @@
       </p:sp>
       <p:sp>
         <p:nvSpPr>
-          <p:cNvPr id="67" name="Text 65"/>
+          <p:cNvPr id="68" name="Text 65"/>
           <p:cNvSpPr/>
           <p:nvPr/>
         </p:nvSpPr>
@@ -8508,7 +8314,7 @@
       </p:sp>
       <p:sp>
         <p:nvSpPr>
-          <p:cNvPr id="68" name="Shape 66"/>
+          <p:cNvPr id="69" name="Shape 66"/>
           <p:cNvSpPr/>
           <p:nvPr/>
         </p:nvSpPr>
@@ -8537,7 +8343,7 @@
       </p:sp>
       <p:sp>
         <p:nvSpPr>
-          <p:cNvPr id="69" name="Shape 67"/>
+          <p:cNvPr id="70" name="Shape 67"/>
           <p:cNvSpPr/>
           <p:nvPr/>
         </p:nvSpPr>
@@ -8550,14 +8356,14 @@
             <a:avLst/>
           </a:prstGeom>
           <a:solidFill>
-            <a:srgbClr val="C0504D"/>
-          </a:solidFill>
-          <a:ln/>
-        </p:spPr>
-      </p:sp>
-      <p:sp>
-        <p:nvSpPr>
-          <p:cNvPr id="70" name="Text 68"/>
+            <a:srgbClr val="B23A2E"/>
+          </a:solidFill>
+          <a:ln/>
+        </p:spPr>
+      </p:sp>
+      <p:sp>
+        <p:nvSpPr>
+          <p:cNvPr id="71" name="Text 68"/>
           <p:cNvSpPr/>
           <p:nvPr/>
         </p:nvSpPr>
@@ -8582,7 +8388,7 @@
             <a:r>
               <a:rPr lang="en-US" sz="2600" b="1" dirty="0">
                 <a:solidFill>
-                  <a:srgbClr val="C0504D"/>
+                  <a:srgbClr val="B23A2E"/>
                 </a:solidFill>
                 <a:latin typeface="Calibri" pitchFamily="34" charset="0"/>
                 <a:ea typeface="Calibri" pitchFamily="34" charset="-122"/>
@@ -8596,7 +8402,7 @@
       </p:sp>
       <p:sp>
         <p:nvSpPr>
-          <p:cNvPr id="71" name="Text 69"/>
+          <p:cNvPr id="72" name="Text 69"/>
           <p:cNvSpPr/>
           <p:nvPr/>
         </p:nvSpPr>

</xml_diff>